<commit_message>
Update ETCE L00 Exercise Dates
</commit_message>
<xml_diff>
--- a/Emerging-Technologies-for-the-Circular-Economy/ETCE-L00-Organization.pptx
+++ b/Emerging-Technologies-for-the-Circular-Economy/ETCE-L00-Organization.pptx
@@ -398,7 +398,7 @@
             <a:pPr indent="0" algn="r">
               <a:buNone/>
             </a:pPr>
-            <a:fld id="{1394D578-B9EA-40DB-B90B-F69503C79590}" type="slidenum">
+            <a:fld id="{0C4E021F-0DC6-41A5-9DDC-447EAB13DB95}" type="slidenum">
               <a:rPr lang="en-US" sz="1400" b="0" u="none" strike="noStrike">
                 <a:solidFill>
                   <a:srgbClr val="000000"/>
@@ -456,7 +456,7 @@
         <p:spPr>
           <a:xfrm>
             <a:off x="533520" y="763560"/>
-            <a:ext cx="6686280" cy="3754440"/>
+            <a:ext cx="6685920" cy="3754080"/>
           </a:xfrm>
           <a:prstGeom prst="rect">
             <a:avLst/>
@@ -479,7 +479,7 @@
         <p:spPr>
           <a:xfrm>
             <a:off x="777240" y="4777560"/>
-            <a:ext cx="6199920" cy="4508280"/>
+            <a:ext cx="6199560" cy="4507920"/>
           </a:xfrm>
           <a:prstGeom prst="rect">
             <a:avLst/>
@@ -517,7 +517,7 @@
         <p:spPr>
           <a:xfrm>
             <a:off x="4399200" y="9555480"/>
-            <a:ext cx="3355200" cy="484920"/>
+            <a:ext cx="3354840" cy="484560"/>
           </a:xfrm>
           <a:prstGeom prst="rect">
             <a:avLst/>
@@ -543,7 +543,7 @@
                 <a:spcPct val="100000"/>
               </a:lnSpc>
             </a:pPr>
-            <a:fld id="{7CF87859-8EC1-4412-86B9-1AD288D2FEEC}" type="slidenum">
+            <a:fld id="{C9A34377-79F7-43B6-B771-A25990933F4F}" type="slidenum">
               <a:rPr lang="de-DE" sz="1800" b="0" u="none" strike="noStrike">
                 <a:solidFill>
                   <a:srgbClr val="000000"/>
@@ -601,7 +601,7 @@
         <p:spPr>
           <a:xfrm>
             <a:off x="533520" y="763560"/>
-            <a:ext cx="6686280" cy="3754440"/>
+            <a:ext cx="6685920" cy="3754080"/>
           </a:xfrm>
           <a:prstGeom prst="rect">
             <a:avLst/>
@@ -624,7 +624,7 @@
         <p:spPr>
           <a:xfrm>
             <a:off x="777240" y="4777560"/>
-            <a:ext cx="6199920" cy="4508280"/>
+            <a:ext cx="6199560" cy="4507920"/>
           </a:xfrm>
           <a:prstGeom prst="rect">
             <a:avLst/>
@@ -662,7 +662,7 @@
         <p:spPr>
           <a:xfrm>
             <a:off x="4399200" y="9555480"/>
-            <a:ext cx="3355200" cy="484920"/>
+            <a:ext cx="3354840" cy="484560"/>
           </a:xfrm>
           <a:prstGeom prst="rect">
             <a:avLst/>
@@ -688,7 +688,7 @@
                 <a:spcPct val="100000"/>
               </a:lnSpc>
             </a:pPr>
-            <a:fld id="{A3E56F4A-F811-47D2-BDF4-06074B29EF60}" type="slidenum">
+            <a:fld id="{24E2D19B-3E56-4A53-BEF3-D92E263EAD02}" type="slidenum">
               <a:rPr lang="de-DE" sz="1800" b="0" u="none" strike="noStrike">
                 <a:solidFill>
                   <a:srgbClr val="000000"/>
@@ -746,7 +746,7 @@
         <p:spPr>
           <a:xfrm>
             <a:off x="533520" y="763560"/>
-            <a:ext cx="6686280" cy="3754440"/>
+            <a:ext cx="6685920" cy="3754080"/>
           </a:xfrm>
           <a:prstGeom prst="rect">
             <a:avLst/>
@@ -769,7 +769,7 @@
         <p:spPr>
           <a:xfrm>
             <a:off x="777240" y="4777560"/>
-            <a:ext cx="6199920" cy="4508280"/>
+            <a:ext cx="6199560" cy="4507920"/>
           </a:xfrm>
           <a:prstGeom prst="rect">
             <a:avLst/>
@@ -807,7 +807,7 @@
         <p:spPr>
           <a:xfrm>
             <a:off x="4399200" y="9555480"/>
-            <a:ext cx="3355200" cy="484920"/>
+            <a:ext cx="3354840" cy="484560"/>
           </a:xfrm>
           <a:prstGeom prst="rect">
             <a:avLst/>
@@ -833,7 +833,7 @@
                 <a:spcPct val="100000"/>
               </a:lnSpc>
             </a:pPr>
-            <a:fld id="{8DDDEFD7-26A8-4A75-98D8-34E2226B1DB5}" type="slidenum">
+            <a:fld id="{56801E0E-BEC0-406A-8658-DE8ADE853C03}" type="slidenum">
               <a:rPr lang="de-DE" sz="1800" b="0" u="none" strike="noStrike">
                 <a:solidFill>
                   <a:srgbClr val="000000"/>
@@ -843,7 +843,7 @@
                 <a:latin typeface="+mn-lt"/>
                 <a:ea typeface="+mn-ea"/>
               </a:rPr>
-              <a:t>&lt;number&gt;</a:t>
+              <a:t>6</a:t>
             </a:fld>
             <a:endParaRPr lang="en-US" sz="1800" b="0" u="none" strike="noStrike">
               <a:solidFill>
@@ -938,7 +938,7 @@
         <p:spPr>
           <a:xfrm>
             <a:off x="11444760" y="0"/>
-            <a:ext cx="734760" cy="6843600"/>
+            <a:ext cx="734400" cy="6843240"/>
           </a:xfrm>
           <a:prstGeom prst="rect">
             <a:avLst/>
@@ -983,7 +983,7 @@
         <p:spPr>
           <a:xfrm>
             <a:off x="11438640" y="6453360"/>
-            <a:ext cx="751680" cy="363960"/>
+            <a:ext cx="751320" cy="363960"/>
           </a:xfrm>
           <a:prstGeom prst="rect">
             <a:avLst/>
@@ -1009,7 +1009,7 @@
                 <a:spcPct val="100000"/>
               </a:lnSpc>
             </a:pPr>
-            <a:fld id="{44BC923B-347E-4ADC-A1E6-DB686A3D3CF2}" type="slidenum">
+            <a:fld id="{2116B04D-B101-4370-8F3A-853A6966F364}" type="slidenum">
               <a:rPr lang="en-US" sz="1800" b="0" u="none" strike="noStrike">
                 <a:solidFill>
                   <a:srgbClr val="808080"/>
@@ -1041,7 +1041,7 @@
         <p:spPr>
           <a:xfrm>
             <a:off x="912240" y="1268280"/>
-            <a:ext cx="9201600" cy="354960"/>
+            <a:ext cx="9201240" cy="354600"/>
           </a:xfrm>
           <a:prstGeom prst="rect">
             <a:avLst/>
@@ -1086,7 +1086,7 @@
         <p:spPr>
           <a:xfrm>
             <a:off x="0" y="0"/>
-            <a:ext cx="3045600" cy="555480"/>
+            <a:ext cx="3045240" cy="555120"/>
           </a:xfrm>
           <a:prstGeom prst="rect">
             <a:avLst/>
@@ -1110,7 +1110,7 @@
         <p:spPr>
           <a:xfrm>
             <a:off x="7430400" y="134640"/>
-            <a:ext cx="3691440" cy="507600"/>
+            <a:ext cx="3691080" cy="507240"/>
           </a:xfrm>
           <a:prstGeom prst="rect">
             <a:avLst/>
@@ -1130,7 +1130,7 @@
         <p:spPr>
           <a:xfrm>
             <a:off x="912240" y="1268280"/>
-            <a:ext cx="9201600" cy="354960"/>
+            <a:ext cx="9201240" cy="354600"/>
           </a:xfrm>
           <a:prstGeom prst="rect">
             <a:avLst/>
@@ -1171,7 +1171,7 @@
         <p:spPr>
           <a:xfrm>
             <a:off x="11444760" y="0"/>
-            <a:ext cx="734760" cy="6843600"/>
+            <a:ext cx="734400" cy="6843240"/>
           </a:xfrm>
           <a:prstGeom prst="rect">
             <a:avLst/>
@@ -1216,7 +1216,7 @@
         <p:spPr>
           <a:xfrm>
             <a:off x="0" y="6642720"/>
-            <a:ext cx="12177720" cy="211320"/>
+            <a:ext cx="12177360" cy="211320"/>
           </a:xfrm>
           <a:prstGeom prst="rect">
             <a:avLst/>
@@ -1295,6 +1295,9 @@
           <a:lstStyle>
             <a:lvl1pPr indent="0" algn="l">
               <a:buNone/>
+              <a:tabLst>
+                <a:tab pos="0" algn="l"/>
+              </a:tabLst>
               <a:defRPr lang="en-US" sz="4400" b="0" u="none" strike="noStrike">
                 <a:solidFill>
                   <a:srgbClr val="000000"/>
@@ -1308,6 +1311,9 @@
           <a:p>
             <a:pPr indent="0" algn="l">
               <a:buNone/>
+              <a:tabLst>
+                <a:tab pos="0" algn="l"/>
+              </a:tabLst>
             </a:pPr>
             <a:r>
               <a:rPr lang="en-US" sz="4400" b="0" u="none" strike="noStrike">
@@ -1717,7 +1723,7 @@
         <p:spPr>
           <a:xfrm>
             <a:off x="11444760" y="0"/>
-            <a:ext cx="734760" cy="6843600"/>
+            <a:ext cx="734400" cy="6843240"/>
           </a:xfrm>
           <a:prstGeom prst="rect">
             <a:avLst/>
@@ -1762,7 +1768,7 @@
         <p:spPr>
           <a:xfrm>
             <a:off x="11438640" y="6453360"/>
-            <a:ext cx="751680" cy="363960"/>
+            <a:ext cx="751320" cy="363960"/>
           </a:xfrm>
           <a:prstGeom prst="rect">
             <a:avLst/>
@@ -1788,7 +1794,7 @@
                 <a:spcPct val="100000"/>
               </a:lnSpc>
             </a:pPr>
-            <a:fld id="{DC8154F4-2805-43C5-A840-742C6C171F80}" type="slidenum">
+            <a:fld id="{2DB44041-47ED-4434-BAAA-AB31F9FF40D3}" type="slidenum">
               <a:rPr lang="en-US" sz="1800" b="0" u="none" strike="noStrike">
                 <a:solidFill>
                   <a:srgbClr val="808080"/>
@@ -1820,7 +1826,7 @@
         <p:spPr>
           <a:xfrm>
             <a:off x="912240" y="1268280"/>
-            <a:ext cx="9201600" cy="354960"/>
+            <a:ext cx="9201240" cy="354600"/>
           </a:xfrm>
           <a:prstGeom prst="rect">
             <a:avLst/>
@@ -1865,7 +1871,7 @@
         <p:spPr>
           <a:xfrm>
             <a:off x="0" y="0"/>
-            <a:ext cx="3045600" cy="555480"/>
+            <a:ext cx="3045240" cy="555120"/>
           </a:xfrm>
           <a:prstGeom prst="rect">
             <a:avLst/>
@@ -1889,7 +1895,7 @@
         <p:spPr>
           <a:xfrm>
             <a:off x="7430400" y="134640"/>
-            <a:ext cx="3691440" cy="507600"/>
+            <a:ext cx="3691080" cy="507240"/>
           </a:xfrm>
           <a:prstGeom prst="rect">
             <a:avLst/>
@@ -1909,7 +1915,7 @@
         <p:spPr>
           <a:xfrm>
             <a:off x="11444760" y="0"/>
-            <a:ext cx="734760" cy="6843600"/>
+            <a:ext cx="734400" cy="6843240"/>
           </a:xfrm>
           <a:prstGeom prst="rect">
             <a:avLst/>
@@ -1954,7 +1960,7 @@
         <p:spPr>
           <a:xfrm>
             <a:off x="11438640" y="6453360"/>
-            <a:ext cx="751680" cy="363960"/>
+            <a:ext cx="751320" cy="363960"/>
           </a:xfrm>
           <a:prstGeom prst="rect">
             <a:avLst/>
@@ -1980,7 +1986,7 @@
                 <a:spcPct val="100000"/>
               </a:lnSpc>
             </a:pPr>
-            <a:fld id="{142CA675-D764-447D-AD69-60313855A84E}" type="slidenum">
+            <a:fld id="{D371301A-A820-4D81-9DBA-640B3FACFD6B}" type="slidenum">
               <a:rPr lang="en-US" sz="1800" b="0" u="none" strike="noStrike">
                 <a:solidFill>
                   <a:srgbClr val="808080"/>
@@ -2012,7 +2018,7 @@
         <p:spPr>
           <a:xfrm>
             <a:off x="0" y="6642720"/>
-            <a:ext cx="12177720" cy="211320"/>
+            <a:ext cx="12177360" cy="211320"/>
           </a:xfrm>
           <a:prstGeom prst="rect">
             <a:avLst/>
@@ -2091,6 +2097,9 @@
           <a:lstStyle>
             <a:lvl1pPr indent="0" algn="l">
               <a:buNone/>
+              <a:tabLst>
+                <a:tab pos="0" algn="l"/>
+              </a:tabLst>
               <a:defRPr lang="en-US" sz="4400" b="0" u="none" strike="noStrike">
                 <a:solidFill>
                   <a:srgbClr val="000000"/>
@@ -2104,6 +2113,9 @@
           <a:p>
             <a:pPr indent="0" algn="l">
               <a:buNone/>
+              <a:tabLst>
+                <a:tab pos="0" algn="l"/>
+              </a:tabLst>
             </a:pPr>
             <a:r>
               <a:rPr lang="en-US" sz="4400" b="0" u="none" strike="noStrike">
@@ -2506,7 +2518,7 @@
         <p:spPr>
           <a:xfrm>
             <a:off x="527400" y="1412640"/>
-            <a:ext cx="10354680" cy="1141200"/>
+            <a:ext cx="10354320" cy="1140840"/>
           </a:xfrm>
           <a:prstGeom prst="rect">
             <a:avLst/>
@@ -2542,103 +2554,7 @@
                 <a:latin typeface="DejaVu Sans"/>
                 <a:ea typeface="DejaVu Sans"/>
               </a:rPr>
-              <a:t>Emerg</a:t>
-            </a:r>
-            <a:r>
-              <a:rPr lang="en-US" sz="3200" b="1" u="none" strike="noStrike">
-                <a:solidFill>
-                  <a:srgbClr val="008C4F"/>
-                </a:solidFill>
-                <a:effectLst/>
-                <a:uFillTx/>
-                <a:latin typeface="DejaVu Sans"/>
-                <a:ea typeface="DejaVu Sans"/>
-              </a:rPr>
-              <a:t>ing </a:t>
-            </a:r>
-            <a:r>
-              <a:rPr lang="en-US" sz="3200" b="1" u="none" strike="noStrike">
-                <a:solidFill>
-                  <a:srgbClr val="008C4F"/>
-                </a:solidFill>
-                <a:effectLst/>
-                <a:uFillTx/>
-                <a:latin typeface="DejaVu Sans"/>
-                <a:ea typeface="DejaVu Sans"/>
-              </a:rPr>
-              <a:t>Techno</a:t>
-            </a:r>
-            <a:r>
-              <a:rPr lang="en-US" sz="3200" b="1" u="none" strike="noStrike">
-                <a:solidFill>
-                  <a:srgbClr val="008C4F"/>
-                </a:solidFill>
-                <a:effectLst/>
-                <a:uFillTx/>
-                <a:latin typeface="DejaVu Sans"/>
-                <a:ea typeface="DejaVu Sans"/>
-              </a:rPr>
-              <a:t>logies </a:t>
-            </a:r>
-            <a:r>
-              <a:rPr lang="en-US" sz="3200" b="1" u="none" strike="noStrike">
-                <a:solidFill>
-                  <a:srgbClr val="008C4F"/>
-                </a:solidFill>
-                <a:effectLst/>
-                <a:uFillTx/>
-                <a:latin typeface="DejaVu Sans"/>
-                <a:ea typeface="DejaVu Sans"/>
-              </a:rPr>
-              <a:t>for the </a:t>
-            </a:r>
-            <a:r>
-              <a:rPr lang="en-US" sz="3200" b="1" u="none" strike="noStrike">
-                <a:solidFill>
-                  <a:srgbClr val="008C4F"/>
-                </a:solidFill>
-                <a:effectLst/>
-                <a:uFillTx/>
-                <a:latin typeface="DejaVu Sans"/>
-                <a:ea typeface="DejaVu Sans"/>
-              </a:rPr>
-              <a:t>Circula</a:t>
-            </a:r>
-            <a:r>
-              <a:rPr lang="en-US" sz="3200" b="1" u="none" strike="noStrike">
-                <a:solidFill>
-                  <a:srgbClr val="008C4F"/>
-                </a:solidFill>
-                <a:effectLst/>
-                <a:uFillTx/>
-                <a:latin typeface="DejaVu Sans"/>
-                <a:ea typeface="DejaVu Sans"/>
-              </a:rPr>
-              <a:t>r </a:t>
-            </a:r>
-            <a:r>
-              <a:rPr lang="en-US" sz="3200" b="1" u="none" strike="noStrike">
-                <a:solidFill>
-                  <a:srgbClr val="008C4F"/>
-                </a:solidFill>
-                <a:effectLst/>
-                <a:uFillTx/>
-                <a:latin typeface="DejaVu Sans"/>
-                <a:ea typeface="DejaVu Sans"/>
-              </a:rPr>
-              <a:t>Econo</a:t>
-            </a:r>
-            <a:r>
-              <a:rPr lang="en-US" sz="3200" b="1" u="none" strike="noStrike">
-                <a:solidFill>
-                  <a:srgbClr val="008C4F"/>
-                </a:solidFill>
-                <a:effectLst/>
-                <a:uFillTx/>
-                <a:latin typeface="DejaVu Sans"/>
-                <a:ea typeface="DejaVu Sans"/>
-              </a:rPr>
-              <a:t>my</a:t>
+              <a:t>Emerging Technologies for the Circular Economy</a:t>
             </a:r>
             <a:endParaRPr lang="en-US" sz="3200" b="0" u="none" strike="noStrike">
               <a:solidFill>
@@ -2660,7 +2576,7 @@
         <p:spPr>
           <a:xfrm>
             <a:off x="527400" y="2852640"/>
-            <a:ext cx="10354680" cy="2361960"/>
+            <a:ext cx="10354320" cy="2361600"/>
           </a:xfrm>
           <a:prstGeom prst="rect">
             <a:avLst/>
@@ -2916,7 +2832,7 @@
         <p:spPr>
           <a:xfrm>
             <a:off x="335520" y="764640"/>
-            <a:ext cx="10738800" cy="489600"/>
+            <a:ext cx="10738440" cy="489240"/>
           </a:xfrm>
           <a:prstGeom prst="rect">
             <a:avLst/>
@@ -2974,7 +2890,7 @@
         <p:spPr>
           <a:xfrm>
             <a:off x="335520" y="1268280"/>
-            <a:ext cx="10738800" cy="5026320"/>
+            <a:ext cx="10738440" cy="5025960"/>
           </a:xfrm>
           <a:prstGeom prst="rect">
             <a:avLst/>
@@ -3456,7 +3372,7 @@
         <p:spPr>
           <a:xfrm>
             <a:off x="335520" y="764640"/>
-            <a:ext cx="10737360" cy="488160"/>
+            <a:ext cx="10737000" cy="487800"/>
           </a:xfrm>
           <a:prstGeom prst="rect">
             <a:avLst/>
@@ -3544,7 +3460,7 @@
         <p:spPr>
           <a:xfrm>
             <a:off x="335520" y="1268640"/>
-            <a:ext cx="10737360" cy="5024880"/>
+            <a:ext cx="10737000" cy="5024520"/>
           </a:xfrm>
           <a:prstGeom prst="rect">
             <a:avLst/>
@@ -4027,7 +3943,7 @@
         <p:spPr>
           <a:xfrm>
             <a:off x="335520" y="764640"/>
-            <a:ext cx="10738800" cy="489600"/>
+            <a:ext cx="10738440" cy="489240"/>
           </a:xfrm>
           <a:prstGeom prst="rect">
             <a:avLst/>
@@ -4085,7 +4001,7 @@
         <p:spPr>
           <a:xfrm>
             <a:off x="335520" y="1268280"/>
-            <a:ext cx="10738800" cy="5026320"/>
+            <a:ext cx="10738440" cy="5025960"/>
           </a:xfrm>
           <a:prstGeom prst="rect">
             <a:avLst/>
@@ -4337,19 +4253,7 @@
                 <a:latin typeface="DejaVu Sans"/>
                 <a:ea typeface="DejaVu Sans"/>
               </a:rPr>
-              <a:t>Submission deadline (coding exercises) is always Monday at 1:59pm (right before the </a:t>
-            </a:r>
-            <a:r>
-              <a:rPr lang="en-GB" sz="1800" b="0" u="none" strike="noStrike">
-                <a:solidFill>
-                  <a:srgbClr val="000000"/>
-                </a:solidFill>
-                <a:effectLst/>
-                <a:uFillTx/>
-                <a:latin typeface="DejaVu Sans"/>
-                <a:ea typeface="DejaVu Sans"/>
-              </a:rPr>
-              <a:t>next lecture)</a:t>
+              <a:t>Submission deadline (coding exercises) is always Monday at 1:59pm (right before the next lecture)</a:t>
             </a:r>
             <a:endParaRPr lang="en-US" sz="1800" b="0" u="none" strike="noStrike">
               <a:solidFill>
@@ -4581,7 +4485,7 @@
         <p:spPr>
           <a:xfrm>
             <a:off x="335520" y="764640"/>
-            <a:ext cx="10738800" cy="489600"/>
+            <a:ext cx="10738440" cy="489240"/>
           </a:xfrm>
           <a:prstGeom prst="rect">
             <a:avLst/>
@@ -4639,7 +4543,7 @@
         <p:spPr>
           <a:xfrm>
             <a:off x="335520" y="1600200"/>
-            <a:ext cx="4465080" cy="4694760"/>
+            <a:ext cx="4464720" cy="4694400"/>
           </a:xfrm>
           <a:prstGeom prst="rect">
             <a:avLst/>
@@ -4743,7 +4647,7 @@
             <a:r>
               <a:rPr lang="de-DE" sz="1800" b="0" u="sng" strike="noStrike">
                 <a:solidFill>
-                  <a:srgbClr val="000000"/>
+                  <a:srgbClr val="0000FF"/>
                 </a:solidFill>
                 <a:effectLst/>
                 <a:uFillTx/>
@@ -4768,7 +4672,7 @@
             <a:r>
               <a:rPr lang="de-DE" sz="1800" b="0" u="none" strike="noStrike">
                 <a:solidFill>
-                  <a:srgbClr val="000000"/>
+                  <a:srgbClr val="0000FF"/>
                 </a:solidFill>
                 <a:effectLst/>
                 <a:uFillTx/>
@@ -4810,7 +4714,7 @@
         <p:spPr>
           <a:xfrm>
             <a:off x="4655880" y="476640"/>
-            <a:ext cx="2424960" cy="351000"/>
+            <a:ext cx="2424600" cy="350640"/>
           </a:xfrm>
           <a:prstGeom prst="rect">
             <a:avLst/>
@@ -4855,7 +4759,7 @@
         <p:spPr>
           <a:xfrm>
             <a:off x="5715000" y="1448280"/>
-            <a:ext cx="4857480" cy="4760280"/>
+            <a:ext cx="4857120" cy="4759920"/>
           </a:xfrm>
           <a:prstGeom prst="rect">
             <a:avLst/>
@@ -4905,7 +4809,7 @@
         <p:spPr>
           <a:xfrm>
             <a:off x="335520" y="764640"/>
-            <a:ext cx="10738800" cy="489600"/>
+            <a:ext cx="10738440" cy="489240"/>
           </a:xfrm>
           <a:prstGeom prst="rect">
             <a:avLst/>
@@ -4963,7 +4867,7 @@
         <p:spPr>
           <a:xfrm>
             <a:off x="335520" y="1600200"/>
-            <a:ext cx="4465080" cy="4694760"/>
+            <a:ext cx="4464720" cy="4694400"/>
           </a:xfrm>
           <a:prstGeom prst="rect">
             <a:avLst/>
@@ -5065,7 +4969,7 @@
         <p:spPr>
           <a:xfrm>
             <a:off x="4655880" y="476640"/>
-            <a:ext cx="2424960" cy="351000"/>
+            <a:ext cx="2424600" cy="350640"/>
           </a:xfrm>
           <a:prstGeom prst="rect">
             <a:avLst/>
@@ -5110,7 +5014,7 @@
         <p:spPr>
           <a:xfrm>
             <a:off x="5715000" y="1448280"/>
-            <a:ext cx="4857480" cy="4760280"/>
+            <a:ext cx="4857120" cy="4759920"/>
           </a:xfrm>
           <a:prstGeom prst="rect">
             <a:avLst/>
@@ -5130,7 +5034,7 @@
         <p:spPr>
           <a:xfrm>
             <a:off x="5943600" y="5535000"/>
-            <a:ext cx="457200" cy="228600"/>
+            <a:ext cx="456840" cy="228240"/>
           </a:xfrm>
           <a:prstGeom prst="rightArrow">
             <a:avLst>
@@ -5208,7 +5112,7 @@
         <p:spPr>
           <a:xfrm>
             <a:off x="335520" y="764640"/>
-            <a:ext cx="10738800" cy="489600"/>
+            <a:ext cx="10738440" cy="489240"/>
           </a:xfrm>
           <a:prstGeom prst="rect">
             <a:avLst/>
@@ -5266,7 +5170,7 @@
         <p:spPr>
           <a:xfrm>
             <a:off x="335520" y="1600200"/>
-            <a:ext cx="4465080" cy="4694760"/>
+            <a:ext cx="4464720" cy="4694400"/>
           </a:xfrm>
           <a:prstGeom prst="rect">
             <a:avLst/>
@@ -5403,7 +5307,7 @@
         <p:spPr>
           <a:xfrm>
             <a:off x="4655880" y="476640"/>
-            <a:ext cx="2424960" cy="351000"/>
+            <a:ext cx="2424600" cy="350640"/>
           </a:xfrm>
           <a:prstGeom prst="rect">
             <a:avLst/>
@@ -5449,7 +5353,7 @@
         <p:spPr>
           <a:xfrm>
             <a:off x="5785920" y="1484280"/>
-            <a:ext cx="5293440" cy="4002120"/>
+            <a:ext cx="5293080" cy="4001760"/>
           </a:xfrm>
           <a:prstGeom prst="rect">
             <a:avLst/>
@@ -5469,7 +5373,7 @@
         <p:spPr>
           <a:xfrm>
             <a:off x="5680800" y="4343400"/>
-            <a:ext cx="457200" cy="228600"/>
+            <a:ext cx="456840" cy="228240"/>
           </a:xfrm>
           <a:prstGeom prst="rightArrow">
             <a:avLst>
@@ -5547,7 +5451,7 @@
         <p:spPr>
           <a:xfrm>
             <a:off x="335520" y="764640"/>
-            <a:ext cx="10738800" cy="489600"/>
+            <a:ext cx="10738440" cy="489240"/>
           </a:xfrm>
           <a:prstGeom prst="rect">
             <a:avLst/>
@@ -5605,7 +5509,7 @@
         <p:spPr>
           <a:xfrm>
             <a:off x="335520" y="1600200"/>
-            <a:ext cx="4465080" cy="4694760"/>
+            <a:ext cx="4464720" cy="4694400"/>
           </a:xfrm>
           <a:prstGeom prst="rect">
             <a:avLst/>
@@ -5777,7 +5681,7 @@
         <p:spPr>
           <a:xfrm>
             <a:off x="4655880" y="476640"/>
-            <a:ext cx="2424960" cy="351000"/>
+            <a:ext cx="2424600" cy="350640"/>
           </a:xfrm>
           <a:prstGeom prst="rect">
             <a:avLst/>
@@ -5817,13 +5721,13 @@
         </p:nvPicPr>
         <p:blipFill>
           <a:blip r:embed="rId1"/>
-          <a:srcRect l="0" t="0" r="0" b="26233"/>
+          <a:srcRect l="0" t="0" r="0" b="26231"/>
           <a:stretch/>
         </p:blipFill>
         <p:spPr>
           <a:xfrm>
             <a:off x="6172200" y="1600200"/>
-            <a:ext cx="4876560" cy="4264200"/>
+            <a:ext cx="4876200" cy="4263840"/>
           </a:xfrm>
           <a:prstGeom prst="rect">
             <a:avLst/>
@@ -5843,7 +5747,7 @@
         <p:spPr>
           <a:xfrm>
             <a:off x="6172200" y="4716000"/>
-            <a:ext cx="457200" cy="228600"/>
+            <a:ext cx="456840" cy="228240"/>
           </a:xfrm>
           <a:prstGeom prst="rightArrow">
             <a:avLst>
@@ -5921,7 +5825,7 @@
         <p:spPr>
           <a:xfrm>
             <a:off x="335520" y="764640"/>
-            <a:ext cx="10738800" cy="489600"/>
+            <a:ext cx="10738440" cy="489240"/>
           </a:xfrm>
           <a:prstGeom prst="rect">
             <a:avLst/>
@@ -5979,7 +5883,7 @@
         <p:spPr>
           <a:xfrm>
             <a:off x="335520" y="1600200"/>
-            <a:ext cx="4465080" cy="4694760"/>
+            <a:ext cx="4464720" cy="4694400"/>
           </a:xfrm>
           <a:prstGeom prst="rect">
             <a:avLst/>
@@ -6186,7 +6090,7 @@
         <p:spPr>
           <a:xfrm>
             <a:off x="4655880" y="476640"/>
-            <a:ext cx="2424960" cy="351000"/>
+            <a:ext cx="2424600" cy="350640"/>
           </a:xfrm>
           <a:prstGeom prst="rect">
             <a:avLst/>
@@ -6231,7 +6135,7 @@
         <p:spPr>
           <a:xfrm>
             <a:off x="6172200" y="1600200"/>
-            <a:ext cx="4343400" cy="4620240"/>
+            <a:ext cx="4343040" cy="4619880"/>
           </a:xfrm>
           <a:prstGeom prst="rect">
             <a:avLst/>
@@ -6281,7 +6185,7 @@
         <p:spPr>
           <a:xfrm>
             <a:off x="335520" y="764640"/>
-            <a:ext cx="10738800" cy="489600"/>
+            <a:ext cx="10738440" cy="489240"/>
           </a:xfrm>
           <a:prstGeom prst="rect">
             <a:avLst/>
@@ -6339,7 +6243,7 @@
         <p:spPr>
           <a:xfrm>
             <a:off x="335520" y="1600200"/>
-            <a:ext cx="10408680" cy="2743200"/>
+            <a:ext cx="10408320" cy="2742840"/>
           </a:xfrm>
           <a:prstGeom prst="rect">
             <a:avLst/>
@@ -6441,7 +6345,7 @@
         <p:spPr>
           <a:xfrm>
             <a:off x="4655880" y="476640"/>
-            <a:ext cx="2424960" cy="351000"/>
+            <a:ext cx="2424600" cy="350640"/>
           </a:xfrm>
           <a:prstGeom prst="rect">
             <a:avLst/>
@@ -6481,13 +6385,13 @@
         </p:nvPicPr>
         <p:blipFill>
           <a:blip r:embed="rId1"/>
-          <a:srcRect l="0" t="0" r="16553" b="0"/>
+          <a:srcRect l="0" t="0" r="16551" b="0"/>
           <a:stretch/>
         </p:blipFill>
         <p:spPr>
           <a:xfrm>
             <a:off x="1067400" y="4343400"/>
-            <a:ext cx="9219600" cy="1962360"/>
+            <a:ext cx="9219240" cy="1962000"/>
           </a:xfrm>
           <a:prstGeom prst="rect">
             <a:avLst/>
@@ -6537,7 +6441,7 @@
         <p:spPr>
           <a:xfrm>
             <a:off x="335520" y="764640"/>
-            <a:ext cx="10738800" cy="489600"/>
+            <a:ext cx="10738440" cy="489240"/>
           </a:xfrm>
           <a:prstGeom prst="rect">
             <a:avLst/>
@@ -6595,7 +6499,7 @@
         <p:spPr>
           <a:xfrm>
             <a:off x="335520" y="1600200"/>
-            <a:ext cx="10408680" cy="2743200"/>
+            <a:ext cx="10408320" cy="2742840"/>
           </a:xfrm>
           <a:prstGeom prst="rect">
             <a:avLst/>
@@ -6732,7 +6636,7 @@
         <p:spPr>
           <a:xfrm>
             <a:off x="4655880" y="476640"/>
-            <a:ext cx="2424960" cy="351000"/>
+            <a:ext cx="2424600" cy="350640"/>
           </a:xfrm>
           <a:prstGeom prst="rect">
             <a:avLst/>
@@ -6777,7 +6681,7 @@
         <p:spPr>
           <a:xfrm>
             <a:off x="2057400" y="3657600"/>
-            <a:ext cx="6495840" cy="2685600"/>
+            <a:ext cx="6495480" cy="2685240"/>
           </a:xfrm>
           <a:prstGeom prst="rect">
             <a:avLst/>
@@ -6827,7 +6731,7 @@
         <p:spPr>
           <a:xfrm>
             <a:off x="335520" y="764640"/>
-            <a:ext cx="10736640" cy="487440"/>
+            <a:ext cx="10736280" cy="487080"/>
           </a:xfrm>
           <a:prstGeom prst="rect">
             <a:avLst/>
@@ -6885,7 +6789,7 @@
         <p:spPr>
           <a:xfrm>
             <a:off x="335520" y="1268640"/>
-            <a:ext cx="10736640" cy="5024160"/>
+            <a:ext cx="10736280" cy="5023800"/>
           </a:xfrm>
           <a:prstGeom prst="rect">
             <a:avLst/>
@@ -6926,7 +6830,7 @@
         <p:spPr>
           <a:xfrm>
             <a:off x="336600" y="3429000"/>
-            <a:ext cx="10854360" cy="2046240"/>
+            <a:ext cx="10854000" cy="2045880"/>
           </a:xfrm>
           <a:prstGeom prst="rect">
             <a:avLst/>
@@ -7139,7 +7043,7 @@
         <p:spPr>
           <a:xfrm>
             <a:off x="335520" y="764640"/>
-            <a:ext cx="10738800" cy="489600"/>
+            <a:ext cx="10738440" cy="489240"/>
           </a:xfrm>
           <a:prstGeom prst="rect">
             <a:avLst/>
@@ -7197,7 +7101,7 @@
         <p:spPr>
           <a:xfrm>
             <a:off x="335520" y="1600200"/>
-            <a:ext cx="10408680" cy="2743200"/>
+            <a:ext cx="10408320" cy="2742840"/>
           </a:xfrm>
           <a:prstGeom prst="rect">
             <a:avLst/>
@@ -7369,7 +7273,7 @@
         <p:spPr>
           <a:xfrm>
             <a:off x="4655880" y="476640"/>
-            <a:ext cx="2424960" cy="351000"/>
+            <a:ext cx="2424600" cy="350640"/>
           </a:xfrm>
           <a:prstGeom prst="rect">
             <a:avLst/>
@@ -7414,7 +7318,7 @@
         <p:spPr>
           <a:xfrm>
             <a:off x="2124360" y="3706200"/>
-            <a:ext cx="5876640" cy="2694600"/>
+            <a:ext cx="5876280" cy="2694240"/>
           </a:xfrm>
           <a:prstGeom prst="rect">
             <a:avLst/>
@@ -7464,7 +7368,7 @@
         <p:spPr>
           <a:xfrm>
             <a:off x="335520" y="764640"/>
-            <a:ext cx="10738800" cy="489600"/>
+            <a:ext cx="10738440" cy="489240"/>
           </a:xfrm>
           <a:prstGeom prst="rect">
             <a:avLst/>
@@ -7522,7 +7426,7 @@
         <p:spPr>
           <a:xfrm>
             <a:off x="335520" y="1600200"/>
-            <a:ext cx="10408680" cy="2743200"/>
+            <a:ext cx="10408320" cy="2742840"/>
           </a:xfrm>
           <a:prstGeom prst="rect">
             <a:avLst/>
@@ -7694,7 +7598,7 @@
         <p:spPr>
           <a:xfrm>
             <a:off x="4655880" y="476640"/>
-            <a:ext cx="2424960" cy="351000"/>
+            <a:ext cx="2424600" cy="350640"/>
           </a:xfrm>
           <a:prstGeom prst="rect">
             <a:avLst/>
@@ -7734,13 +7638,13 @@
         </p:nvPicPr>
         <p:blipFill>
           <a:blip r:embed="rId1"/>
-          <a:srcRect l="0" t="24696" r="0" b="0"/>
+          <a:srcRect l="0" t="24691" r="0" b="0"/>
           <a:stretch/>
         </p:blipFill>
         <p:spPr>
           <a:xfrm>
             <a:off x="5063400" y="3056400"/>
-            <a:ext cx="5656680" cy="3657240"/>
+            <a:ext cx="5656320" cy="3656880"/>
           </a:xfrm>
           <a:prstGeom prst="rect">
             <a:avLst/>
@@ -7790,7 +7694,7 @@
         <p:spPr>
           <a:xfrm>
             <a:off x="335520" y="764640"/>
-            <a:ext cx="10738800" cy="489600"/>
+            <a:ext cx="10738440" cy="489240"/>
           </a:xfrm>
           <a:prstGeom prst="rect">
             <a:avLst/>
@@ -7848,7 +7752,7 @@
         <p:spPr>
           <a:xfrm>
             <a:off x="335520" y="1600200"/>
-            <a:ext cx="10408680" cy="2743200"/>
+            <a:ext cx="10408320" cy="2742840"/>
           </a:xfrm>
           <a:prstGeom prst="rect">
             <a:avLst/>
@@ -8013,19 +7917,13 @@
             </a:endParaRPr>
           </a:p>
           <a:p>
-            <a:pPr marL="432000" lvl="1" indent="-216000">
+            <a:pPr>
               <a:lnSpc>
                 <a:spcPct val="100000"/>
               </a:lnSpc>
               <a:spcBef>
                 <a:spcPts val="360"/>
               </a:spcBef>
-              <a:buClr>
-                <a:srgbClr val="000000"/>
-              </a:buClr>
-              <a:buSzPct val="45000"/>
-              <a:buFont typeface="Wingdings" charset="2"/>
-              <a:buChar char=""/>
             </a:pPr>
             <a:endParaRPr lang="en-US" sz="1800" b="0" u="none" strike="noStrike">
               <a:solidFill>
@@ -8047,7 +7945,7 @@
         <p:spPr>
           <a:xfrm>
             <a:off x="4655880" y="476640"/>
-            <a:ext cx="2424960" cy="351000"/>
+            <a:ext cx="2424600" cy="350640"/>
           </a:xfrm>
           <a:prstGeom prst="rect">
             <a:avLst/>
@@ -8118,7 +8016,7 @@
         <p:spPr>
           <a:xfrm>
             <a:off x="335520" y="764640"/>
-            <a:ext cx="10738800" cy="489600"/>
+            <a:ext cx="10738440" cy="489240"/>
           </a:xfrm>
           <a:prstGeom prst="rect">
             <a:avLst/>
@@ -8176,7 +8074,7 @@
         <p:spPr>
           <a:xfrm>
             <a:off x="335520" y="1600200"/>
-            <a:ext cx="10408680" cy="2743200"/>
+            <a:ext cx="10408320" cy="2742840"/>
           </a:xfrm>
           <a:prstGeom prst="rect">
             <a:avLst/>
@@ -8377,19 +8275,13 @@
             </a:endParaRPr>
           </a:p>
           <a:p>
-            <a:pPr marL="432000" lvl="1" indent="-216000">
+            <a:pPr>
               <a:lnSpc>
                 <a:spcPct val="100000"/>
               </a:lnSpc>
               <a:spcBef>
                 <a:spcPts val="360"/>
               </a:spcBef>
-              <a:buClr>
-                <a:srgbClr val="000000"/>
-              </a:buClr>
-              <a:buSzPct val="45000"/>
-              <a:buFont typeface="Wingdings" charset="2"/>
-              <a:buChar char=""/>
             </a:pPr>
             <a:endParaRPr lang="en-US" sz="1800" b="0" u="none" strike="noStrike">
               <a:solidFill>
@@ -8411,7 +8303,7 @@
         <p:spPr>
           <a:xfrm>
             <a:off x="4655880" y="476640"/>
-            <a:ext cx="2424960" cy="351000"/>
+            <a:ext cx="2424600" cy="350640"/>
           </a:xfrm>
           <a:prstGeom prst="rect">
             <a:avLst/>
@@ -8456,7 +8348,7 @@
         <p:spPr>
           <a:xfrm>
             <a:off x="2372040" y="3657600"/>
-            <a:ext cx="7229160" cy="2857320"/>
+            <a:ext cx="7228800" cy="2856960"/>
           </a:xfrm>
           <a:prstGeom prst="rect">
             <a:avLst/>
@@ -8506,7 +8398,7 @@
         <p:spPr>
           <a:xfrm>
             <a:off x="335520" y="764640"/>
-            <a:ext cx="10738800" cy="489600"/>
+            <a:ext cx="10738440" cy="489240"/>
           </a:xfrm>
           <a:prstGeom prst="rect">
             <a:avLst/>
@@ -8564,7 +8456,7 @@
         <p:spPr>
           <a:xfrm>
             <a:off x="335520" y="1600200"/>
-            <a:ext cx="10408680" cy="2743200"/>
+            <a:ext cx="10408320" cy="2742840"/>
           </a:xfrm>
           <a:prstGeom prst="rect">
             <a:avLst/>
@@ -8801,19 +8693,13 @@
             </a:endParaRPr>
           </a:p>
           <a:p>
-            <a:pPr marL="432000" lvl="1" indent="-216000">
+            <a:pPr>
               <a:lnSpc>
                 <a:spcPct val="100000"/>
               </a:lnSpc>
               <a:spcBef>
                 <a:spcPts val="360"/>
               </a:spcBef>
-              <a:buClr>
-                <a:srgbClr val="000000"/>
-              </a:buClr>
-              <a:buSzPct val="45000"/>
-              <a:buFont typeface="Wingdings" charset="2"/>
-              <a:buChar char=""/>
             </a:pPr>
             <a:endParaRPr lang="en-US" sz="1800" b="0" u="none" strike="noStrike">
               <a:solidFill>
@@ -8835,7 +8721,7 @@
         <p:spPr>
           <a:xfrm>
             <a:off x="4655880" y="476640"/>
-            <a:ext cx="2424960" cy="351000"/>
+            <a:ext cx="2424600" cy="350640"/>
           </a:xfrm>
           <a:prstGeom prst="rect">
             <a:avLst/>
@@ -8880,7 +8766,7 @@
         <p:spPr>
           <a:xfrm>
             <a:off x="2971800" y="3777480"/>
-            <a:ext cx="6172200" cy="2623320"/>
+            <a:ext cx="6171840" cy="2622960"/>
           </a:xfrm>
           <a:prstGeom prst="rect">
             <a:avLst/>
@@ -8930,7 +8816,7 @@
         <p:spPr>
           <a:xfrm>
             <a:off x="335520" y="764640"/>
-            <a:ext cx="10738800" cy="489600"/>
+            <a:ext cx="10738440" cy="489240"/>
           </a:xfrm>
           <a:prstGeom prst="rect">
             <a:avLst/>
@@ -8988,7 +8874,7 @@
         <p:spPr>
           <a:xfrm>
             <a:off x="335520" y="1600200"/>
-            <a:ext cx="10408680" cy="2743200"/>
+            <a:ext cx="10408320" cy="2742840"/>
           </a:xfrm>
           <a:prstGeom prst="rect">
             <a:avLst/>
@@ -9261,19 +9147,13 @@
             </a:endParaRPr>
           </a:p>
           <a:p>
-            <a:pPr marL="432000" lvl="1" indent="-216000">
+            <a:pPr>
               <a:lnSpc>
                 <a:spcPct val="100000"/>
               </a:lnSpc>
               <a:spcBef>
                 <a:spcPts val="360"/>
               </a:spcBef>
-              <a:buClr>
-                <a:srgbClr val="000000"/>
-              </a:buClr>
-              <a:buSzPct val="45000"/>
-              <a:buFont typeface="Wingdings" charset="2"/>
-              <a:buChar char=""/>
             </a:pPr>
             <a:endParaRPr lang="en-US" sz="1800" b="0" u="none" strike="noStrike">
               <a:solidFill>
@@ -9295,7 +9175,7 @@
         <p:spPr>
           <a:xfrm>
             <a:off x="4655880" y="476640"/>
-            <a:ext cx="2424960" cy="351000"/>
+            <a:ext cx="2424600" cy="350640"/>
           </a:xfrm>
           <a:prstGeom prst="rect">
             <a:avLst/>
@@ -9366,7 +9246,7 @@
         <p:spPr>
           <a:xfrm>
             <a:off x="335520" y="768240"/>
-            <a:ext cx="10738800" cy="489600"/>
+            <a:ext cx="10738440" cy="489240"/>
           </a:xfrm>
           <a:prstGeom prst="rect">
             <a:avLst/>
@@ -9424,7 +9304,7 @@
         <p:spPr>
           <a:xfrm>
             <a:off x="388800" y="1488600"/>
-            <a:ext cx="10712520" cy="3505320"/>
+            <a:ext cx="10712160" cy="3505320"/>
           </a:xfrm>
           <a:prstGeom prst="rect">
             <a:avLst/>
@@ -9460,19 +9340,7 @@
                 <a:latin typeface="DejaVu Sans"/>
                 <a:ea typeface="Arial"/>
               </a:rPr>
-              <a:t>Every student enrolled in this course is advised to take the knowledge quiz in first two weeks of </a:t>
-            </a:r>
-            <a:r>
-              <a:rPr lang="de-DE" sz="1400" b="1" u="none" strike="noStrike">
-                <a:solidFill>
-                  <a:srgbClr val="008C4F"/>
-                </a:solidFill>
-                <a:effectLst/>
-                <a:uFillTx/>
-                <a:latin typeface="DejaVu Sans"/>
-                <a:ea typeface="Arial"/>
-              </a:rPr>
-              <a:t>the course.  </a:t>
+              <a:t>Every student enrolled in this course is advised to take the knowledge quiz in first two weeks of the course.  </a:t>
             </a:r>
             <a:endParaRPr lang="en-US" sz="1400" b="0" u="none" strike="noStrike">
               <a:solidFill>
@@ -9661,19 +9529,7 @@
                 <a:latin typeface="DejaVu Sans"/>
                 <a:ea typeface="Arial Unicode MS"/>
               </a:rPr>
-              <a:t>A review of basic concepts of Cryptography and Circular Economy is recommended for Week 1 and Week 2 </a:t>
-            </a:r>
-            <a:r>
-              <a:rPr lang="de-DE" sz="1400" b="0" u="none" strike="noStrike">
-                <a:solidFill>
-                  <a:srgbClr val="000000"/>
-                </a:solidFill>
-                <a:effectLst/>
-                <a:uFillTx/>
-                <a:latin typeface="DejaVu Sans"/>
-                <a:ea typeface="Arial Unicode MS"/>
-              </a:rPr>
-              <a:t>respectively</a:t>
+              <a:t>A review of basic concepts of Cryptography and Circular Economy is recommended for Week 1 and Week 2 respectively</a:t>
             </a:r>
             <a:endParaRPr lang="en-US" sz="1400" b="0" u="none" strike="noStrike">
               <a:solidFill>
@@ -9863,7 +9719,7 @@
         <p:spPr>
           <a:xfrm>
             <a:off x="335520" y="768240"/>
-            <a:ext cx="10738800" cy="489600"/>
+            <a:ext cx="10738440" cy="489240"/>
           </a:xfrm>
           <a:prstGeom prst="rect">
             <a:avLst/>
@@ -9921,7 +9777,7 @@
         <p:spPr>
           <a:xfrm>
             <a:off x="388800" y="1488600"/>
-            <a:ext cx="10712520" cy="3505320"/>
+            <a:ext cx="10712160" cy="3505320"/>
           </a:xfrm>
           <a:prstGeom prst="rect">
             <a:avLst/>
@@ -9957,19 +9813,7 @@
                 <a:latin typeface="DejaVu Sans"/>
                 <a:ea typeface="Arial"/>
               </a:rPr>
-              <a:t>Every student enrolled in this course is advised to take the knowledge quiz in first two weeks of the </a:t>
-            </a:r>
-            <a:r>
-              <a:rPr lang="de-DE" sz="1400" b="1" u="none" strike="noStrike">
-                <a:solidFill>
-                  <a:srgbClr val="008C4F"/>
-                </a:solidFill>
-                <a:effectLst/>
-                <a:uFillTx/>
-                <a:latin typeface="DejaVu Sans"/>
-                <a:ea typeface="Arial"/>
-              </a:rPr>
-              <a:t>course.  </a:t>
+              <a:t>Every student enrolled in this course is advised to take the knowledge quiz in first two weeks of the course.  </a:t>
             </a:r>
             <a:endParaRPr lang="en-US" sz="1400" b="0" u="none" strike="noStrike">
               <a:solidFill>
@@ -10158,19 +10002,7 @@
                 <a:latin typeface="DejaVu Sans"/>
                 <a:ea typeface="Arial Unicode MS"/>
               </a:rPr>
-              <a:t>A review of basic concepts of Cryptography and Circular Economy is recommended for Week 1 and Week 2 </a:t>
-            </a:r>
-            <a:r>
-              <a:rPr lang="de-DE" sz="1400" b="0" u="none" strike="noStrike">
-                <a:solidFill>
-                  <a:srgbClr val="000000"/>
-                </a:solidFill>
-                <a:effectLst/>
-                <a:uFillTx/>
-                <a:latin typeface="DejaVu Sans"/>
-                <a:ea typeface="Arial Unicode MS"/>
-              </a:rPr>
-              <a:t>respectively</a:t>
+              <a:t>A review of basic concepts of Cryptography and Circular Economy is recommended for Week 1 and Week 2 respectively</a:t>
             </a:r>
             <a:endParaRPr lang="en-US" sz="1400" b="0" u="none" strike="noStrike">
               <a:solidFill>
@@ -10384,7 +10216,7 @@
         <p:spPr>
           <a:xfrm>
             <a:off x="335520" y="764640"/>
-            <a:ext cx="10738800" cy="489600"/>
+            <a:ext cx="10738440" cy="489240"/>
           </a:xfrm>
           <a:prstGeom prst="rect">
             <a:avLst/>
@@ -10446,7 +10278,7 @@
         <p:spPr>
           <a:xfrm>
             <a:off x="3200400" y="685800"/>
-            <a:ext cx="5273640" cy="5998320"/>
+            <a:ext cx="5273280" cy="5997960"/>
           </a:xfrm>
           <a:prstGeom prst="rect">
             <a:avLst/>
@@ -10496,7 +10328,7 @@
         <p:spPr>
           <a:xfrm>
             <a:off x="335520" y="764640"/>
-            <a:ext cx="10738800" cy="489600"/>
+            <a:ext cx="10738440" cy="489240"/>
           </a:xfrm>
           <a:prstGeom prst="rect">
             <a:avLst/>
@@ -10558,7 +10390,7 @@
         <p:spPr>
           <a:xfrm>
             <a:off x="1600200" y="1600200"/>
-            <a:ext cx="8359920" cy="4628520"/>
+            <a:ext cx="8359560" cy="4628160"/>
           </a:xfrm>
           <a:prstGeom prst="rect">
             <a:avLst/>
@@ -10608,7 +10440,7 @@
         <p:spPr>
           <a:xfrm>
             <a:off x="335520" y="764640"/>
-            <a:ext cx="10738800" cy="489600"/>
+            <a:ext cx="10738440" cy="489240"/>
           </a:xfrm>
           <a:prstGeom prst="rect">
             <a:avLst/>
@@ -10670,7 +10502,7 @@
         <p:spPr>
           <a:xfrm>
             <a:off x="4923720" y="1257120"/>
-            <a:ext cx="1461600" cy="2162880"/>
+            <a:ext cx="1461240" cy="2162520"/>
           </a:xfrm>
           <a:prstGeom prst="rect">
             <a:avLst/>
@@ -10694,7 +10526,7 @@
         <p:spPr>
           <a:xfrm>
             <a:off x="2207880" y="4110120"/>
-            <a:ext cx="1775520" cy="1767600"/>
+            <a:ext cx="1775160" cy="1767240"/>
           </a:xfrm>
           <a:prstGeom prst="rect">
             <a:avLst/>
@@ -10714,7 +10546,7 @@
         <p:spPr>
           <a:xfrm>
             <a:off x="3859200" y="3373200"/>
-            <a:ext cx="3626280" cy="667800"/>
+            <a:ext cx="3625920" cy="667440"/>
           </a:xfrm>
           <a:prstGeom prst="rect">
             <a:avLst/>
@@ -10775,7 +10607,7 @@
         <p:spPr>
           <a:xfrm>
             <a:off x="1312200" y="5920200"/>
-            <a:ext cx="3626280" cy="667800"/>
+            <a:ext cx="3625920" cy="667440"/>
           </a:xfrm>
           <a:prstGeom prst="rect">
             <a:avLst/>
@@ -10816,7 +10648,7 @@
         <p:spPr>
           <a:xfrm>
             <a:off x="1312200" y="5807160"/>
-            <a:ext cx="3626280" cy="667800"/>
+            <a:ext cx="3625920" cy="667440"/>
           </a:xfrm>
           <a:prstGeom prst="rect">
             <a:avLst/>
@@ -10877,7 +10709,7 @@
         <p:spPr>
           <a:xfrm>
             <a:off x="4860000" y="5920200"/>
-            <a:ext cx="3626280" cy="667800"/>
+            <a:ext cx="3625920" cy="667440"/>
           </a:xfrm>
           <a:prstGeom prst="rect">
             <a:avLst/>
@@ -10918,7 +10750,7 @@
         <p:spPr>
           <a:xfrm>
             <a:off x="6300000" y="5807160"/>
-            <a:ext cx="3626280" cy="667800"/>
+            <a:ext cx="3625920" cy="667440"/>
           </a:xfrm>
           <a:prstGeom prst="rect">
             <a:avLst/>
@@ -10984,7 +10816,7 @@
         <p:spPr>
           <a:xfrm>
             <a:off x="7203960" y="4143960"/>
-            <a:ext cx="1794960" cy="1794960"/>
+            <a:ext cx="1794600" cy="1794600"/>
           </a:xfrm>
           <a:prstGeom prst="rect">
             <a:avLst/>
@@ -11034,7 +10866,7 @@
         <p:spPr>
           <a:xfrm>
             <a:off x="335520" y="764640"/>
-            <a:ext cx="10738800" cy="489600"/>
+            <a:ext cx="10738440" cy="489240"/>
           </a:xfrm>
           <a:prstGeom prst="rect">
             <a:avLst/>
@@ -11092,7 +10924,7 @@
         <p:spPr>
           <a:xfrm>
             <a:off x="335520" y="1268640"/>
-            <a:ext cx="10738800" cy="5026320"/>
+            <a:ext cx="10738440" cy="5025960"/>
           </a:xfrm>
           <a:prstGeom prst="rect">
             <a:avLst/>
@@ -11363,7 +11195,7 @@
         <p:spPr>
           <a:xfrm>
             <a:off x="335520" y="764640"/>
-            <a:ext cx="10737000" cy="487800"/>
+            <a:ext cx="10736640" cy="487440"/>
           </a:xfrm>
           <a:prstGeom prst="rect">
             <a:avLst/>
@@ -11421,7 +11253,7 @@
         <p:spPr>
           <a:xfrm>
             <a:off x="335520" y="1268280"/>
-            <a:ext cx="10737000" cy="5024520"/>
+            <a:ext cx="10736640" cy="5024160"/>
           </a:xfrm>
           <a:prstGeom prst="rect">
             <a:avLst/>
@@ -11527,7 +11359,7 @@
         <p:spPr>
           <a:xfrm>
             <a:off x="6285600" y="2132640"/>
-            <a:ext cx="506520" cy="486360"/>
+            <a:ext cx="506160" cy="486000"/>
           </a:xfrm>
           <a:prstGeom prst="star5">
             <a:avLst>
@@ -11584,7 +11416,7 @@
         <p:spPr>
           <a:xfrm>
             <a:off x="4089960" y="2247480"/>
-            <a:ext cx="2274840" cy="363960"/>
+            <a:ext cx="2274480" cy="363960"/>
           </a:xfrm>
           <a:prstGeom prst="rect">
             <a:avLst/>
@@ -11696,7 +11528,7 @@
         <p:spPr>
           <a:xfrm>
             <a:off x="335520" y="764640"/>
-            <a:ext cx="10737000" cy="487800"/>
+            <a:ext cx="10736640" cy="487440"/>
           </a:xfrm>
           <a:prstGeom prst="rect">
             <a:avLst/>
@@ -11754,7 +11586,7 @@
         <p:spPr>
           <a:xfrm>
             <a:off x="335520" y="1268640"/>
-            <a:ext cx="10737000" cy="5024520"/>
+            <a:ext cx="10736640" cy="5024160"/>
           </a:xfrm>
           <a:prstGeom prst="rect">
             <a:avLst/>
@@ -11823,7 +11655,7 @@
                 <a:latin typeface="DejaVu Sans"/>
                 <a:ea typeface="DejaVu Sans"/>
               </a:rPr>
-              <a:t> need to buy a book to pass </a:t>
+              <a:t> need to buy a book to pass the </a:t>
             </a:r>
             <a:r>
               <a:rPr lang="en-US" sz="1800" b="0" u="none" strike="noStrike">
@@ -11835,7 +11667,7 @@
                 <a:latin typeface="DejaVu Sans"/>
                 <a:ea typeface="DejaVu Sans"/>
               </a:rPr>
-              <a:t>the exam.</a:t>
+              <a:t>exam.</a:t>
             </a:r>
             <a:endParaRPr lang="en-US" sz="1800" b="0" u="none" strike="noStrike">
               <a:solidFill>
@@ -11973,7 +11805,7 @@
                 <a:latin typeface="DejaVu Sans"/>
                 <a:ea typeface="DejaVu Sans"/>
               </a:rPr>
-              <a:t>Limits To Growth: The </a:t>
+              <a:t>Limits To Growth: The 30-</a:t>
             </a:r>
             <a:r>
               <a:rPr lang="en-US" sz="1800" b="0" i="1" u="none" strike="noStrike">
@@ -11985,7 +11817,7 @@
                 <a:latin typeface="DejaVu Sans"/>
                 <a:ea typeface="DejaVu Sans"/>
               </a:rPr>
-              <a:t>30-Year Update</a:t>
+              <a:t>Year Update</a:t>
             </a:r>
             <a:r>
               <a:rPr lang="en-US" sz="1800" b="0" u="none" strike="noStrike">
@@ -12349,7 +12181,7 @@
         <p:spPr>
           <a:xfrm>
             <a:off x="335520" y="764640"/>
-            <a:ext cx="10738800" cy="489600"/>
+            <a:ext cx="10738440" cy="489240"/>
           </a:xfrm>
           <a:prstGeom prst="rect">
             <a:avLst/>
@@ -12407,7 +12239,7 @@
         <p:spPr>
           <a:xfrm>
             <a:off x="335520" y="1268640"/>
-            <a:ext cx="10738800" cy="5026320"/>
+            <a:ext cx="10738440" cy="5025960"/>
           </a:xfrm>
           <a:prstGeom prst="rect">
             <a:avLst/>
@@ -12726,7 +12558,7 @@
         <p:spPr>
           <a:xfrm>
             <a:off x="335520" y="1268640"/>
-            <a:ext cx="10738800" cy="5026320"/>
+            <a:ext cx="10738440" cy="5025960"/>
           </a:xfrm>
           <a:prstGeom prst="rect">
             <a:avLst/>
@@ -12790,7 +12622,7 @@
         <p:spPr>
           <a:xfrm>
             <a:off x="335520" y="764640"/>
-            <a:ext cx="10738800" cy="489600"/>
+            <a:ext cx="10738440" cy="489240"/>
           </a:xfrm>
           <a:prstGeom prst="rect">
             <a:avLst/>
@@ -12861,7 +12693,7 @@
         <p:spPr>
           <a:xfrm>
             <a:off x="542880" y="721800"/>
-            <a:ext cx="10343160" cy="483840"/>
+            <a:ext cx="10342800" cy="483480"/>
           </a:xfrm>
           <a:prstGeom prst="rect">
             <a:avLst/>
@@ -12919,7 +12751,7 @@
         <p:spPr>
           <a:xfrm>
             <a:off x="451800" y="1709280"/>
-            <a:ext cx="8210520" cy="4338720"/>
+            <a:ext cx="8210160" cy="4338360"/>
           </a:xfrm>
           <a:prstGeom prst="rect">
             <a:avLst/>
@@ -12960,7 +12792,7 @@
         <p:spPr>
           <a:xfrm>
             <a:off x="609480" y="1769400"/>
-            <a:ext cx="10573560" cy="4841640"/>
+            <a:ext cx="10573200" cy="4841280"/>
           </a:xfrm>
           <a:prstGeom prst="rect">
             <a:avLst/>
@@ -13441,7 +13273,7 @@
         <p:spPr>
           <a:xfrm>
             <a:off x="542880" y="721800"/>
-            <a:ext cx="10343160" cy="483840"/>
+            <a:ext cx="10342800" cy="483480"/>
           </a:xfrm>
           <a:prstGeom prst="rect">
             <a:avLst/>
@@ -13499,7 +13331,7 @@
         <p:spPr>
           <a:xfrm>
             <a:off x="451800" y="1709280"/>
-            <a:ext cx="8210520" cy="4338720"/>
+            <a:ext cx="8210160" cy="4338360"/>
           </a:xfrm>
           <a:prstGeom prst="rect">
             <a:avLst/>
@@ -13540,7 +13372,7 @@
         <p:spPr>
           <a:xfrm>
             <a:off x="609480" y="1769400"/>
-            <a:ext cx="10573560" cy="4841640"/>
+            <a:ext cx="10573200" cy="4841280"/>
           </a:xfrm>
           <a:prstGeom prst="rect">
             <a:avLst/>
@@ -13821,7 +13653,7 @@
         <p:spPr>
           <a:xfrm>
             <a:off x="542880" y="721800"/>
-            <a:ext cx="10343160" cy="483840"/>
+            <a:ext cx="10342800" cy="483480"/>
           </a:xfrm>
           <a:prstGeom prst="rect">
             <a:avLst/>
@@ -13879,7 +13711,7 @@
         <p:spPr>
           <a:xfrm>
             <a:off x="451800" y="1709280"/>
-            <a:ext cx="8210520" cy="4338720"/>
+            <a:ext cx="8210160" cy="4338360"/>
           </a:xfrm>
           <a:prstGeom prst="rect">
             <a:avLst/>
@@ -13920,7 +13752,7 @@
         <p:spPr>
           <a:xfrm>
             <a:off x="609480" y="1769400"/>
-            <a:ext cx="10573560" cy="4841640"/>
+            <a:ext cx="10573200" cy="4841280"/>
           </a:xfrm>
           <a:prstGeom prst="rect">
             <a:avLst/>
@@ -14201,7 +14033,7 @@
         <p:spPr>
           <a:xfrm>
             <a:off x="335520" y="764640"/>
-            <a:ext cx="10738800" cy="489600"/>
+            <a:ext cx="10738440" cy="489240"/>
           </a:xfrm>
           <a:prstGeom prst="rect">
             <a:avLst/>
@@ -14274,7 +14106,7 @@
         <p:spPr>
           <a:xfrm>
             <a:off x="335520" y="2408400"/>
-            <a:ext cx="10738800" cy="3886560"/>
+            <a:ext cx="10738440" cy="3886200"/>
           </a:xfrm>
           <a:prstGeom prst="rect">
             <a:avLst/>
@@ -14319,19 +14151,7 @@
                 <a:latin typeface="DejaVu Sans"/>
                 <a:ea typeface="DejaVu Sans"/>
               </a:rPr>
-              <a:t>Basic understanding of the concept of the </a:t>
-            </a:r>
-            <a:r>
-              <a:rPr lang="en-US" sz="1800" b="0" u="none" strike="noStrike">
-                <a:solidFill>
-                  <a:srgbClr val="000000"/>
-                </a:solidFill>
-                <a:effectLst/>
-                <a:uFillTx/>
-                <a:latin typeface="DejaVu Sans"/>
-                <a:ea typeface="DejaVu Sans"/>
-              </a:rPr>
-              <a:t>circular economy</a:t>
+              <a:t>Basic understanding of the concept of the circular economy</a:t>
             </a:r>
             <a:endParaRPr lang="en-US" sz="1800" b="0" u="none" strike="noStrike">
               <a:solidFill>
@@ -14367,31 +14187,7 @@
                 <a:latin typeface="DejaVu Sans"/>
                 <a:ea typeface="DejaVu Sans"/>
               </a:rPr>
-              <a:t>Basic understanding of emerging technologies </a:t>
-            </a:r>
-            <a:r>
-              <a:rPr lang="en-US" sz="1800" b="0" u="none" strike="noStrike">
-                <a:solidFill>
-                  <a:srgbClr val="000000"/>
-                </a:solidFill>
-                <a:effectLst/>
-                <a:uFillTx/>
-                <a:latin typeface="DejaVu Sans"/>
-                <a:ea typeface="DejaVu Sans"/>
-              </a:rPr>
-              <a:t>at the intersection of digital technologies and </a:t>
-            </a:r>
-            <a:r>
-              <a:rPr lang="en-US" sz="1800" b="0" u="none" strike="noStrike">
-                <a:solidFill>
-                  <a:srgbClr val="000000"/>
-                </a:solidFill>
-                <a:effectLst/>
-                <a:uFillTx/>
-                <a:latin typeface="DejaVu Sans"/>
-                <a:ea typeface="DejaVu Sans"/>
-              </a:rPr>
-              <a:t>sustainability</a:t>
+              <a:t>Basic understanding of emerging technologies at the intersection of digital technologies and sustainability</a:t>
             </a:r>
             <a:endParaRPr lang="en-US" sz="1800" b="0" u="none" strike="noStrike">
               <a:solidFill>
@@ -14427,19 +14223,7 @@
                 <a:latin typeface="DejaVu Sans"/>
                 <a:ea typeface="DejaVu Sans"/>
               </a:rPr>
-              <a:t>Understanding and overview of the Internet of </a:t>
-            </a:r>
-            <a:r>
-              <a:rPr lang="en-US" sz="1800" b="0" u="none" strike="noStrike">
-                <a:solidFill>
-                  <a:srgbClr val="000000"/>
-                </a:solidFill>
-                <a:effectLst/>
-                <a:uFillTx/>
-                <a:latin typeface="DejaVu Sans"/>
-                <a:ea typeface="DejaVu Sans"/>
-              </a:rPr>
-              <a:t>Things and related concepts</a:t>
+              <a:t>Understanding and overview of the Internet of Things and related concepts</a:t>
             </a:r>
             <a:endParaRPr lang="en-US" sz="1800" b="0" u="none" strike="noStrike">
               <a:solidFill>
@@ -14475,31 +14259,7 @@
                 <a:latin typeface="DejaVu Sans"/>
                 <a:ea typeface="DejaVu Sans"/>
               </a:rPr>
-              <a:t>Ability to design smart systems and </a:t>
-            </a:r>
-            <a:r>
-              <a:rPr lang="en-US" sz="1800" b="0" u="none" strike="noStrike">
-                <a:solidFill>
-                  <a:srgbClr val="000000"/>
-                </a:solidFill>
-                <a:effectLst/>
-                <a:uFillTx/>
-                <a:latin typeface="DejaVu Sans"/>
-                <a:ea typeface="DejaVu Sans"/>
-              </a:rPr>
-              <a:t>applications in the context of connected </a:t>
-            </a:r>
-            <a:r>
-              <a:rPr lang="en-US" sz="1800" b="0" u="none" strike="noStrike">
-                <a:solidFill>
-                  <a:srgbClr val="000000"/>
-                </a:solidFill>
-                <a:effectLst/>
-                <a:uFillTx/>
-                <a:latin typeface="DejaVu Sans"/>
-                <a:ea typeface="DejaVu Sans"/>
-              </a:rPr>
-              <a:t>sensor systems and other stakeholders.</a:t>
+              <a:t>Ability to design smart systems and applications in the context of connected sensor systems and other stakeholders.</a:t>
             </a:r>
             <a:endParaRPr lang="en-US" sz="1800" b="0" u="none" strike="noStrike">
               <a:solidFill>
@@ -14535,19 +14295,7 @@
                 <a:latin typeface="DejaVu Sans"/>
                 <a:ea typeface="DejaVu Sans"/>
               </a:rPr>
-              <a:t>Experience in prototyping applications and </a:t>
-            </a:r>
-            <a:r>
-              <a:rPr lang="en-US" sz="1800" b="0" u="none" strike="noStrike">
-                <a:solidFill>
-                  <a:srgbClr val="000000"/>
-                </a:solidFill>
-                <a:effectLst/>
-                <a:uFillTx/>
-                <a:latin typeface="DejaVu Sans"/>
-                <a:ea typeface="DejaVu Sans"/>
-              </a:rPr>
-              <a:t>systems</a:t>
+              <a:t>Experience in prototyping applications and systems</a:t>
             </a:r>
             <a:endParaRPr lang="en-US" sz="1800" b="0" u="none" strike="noStrike">
               <a:solidFill>
@@ -14599,7 +14347,7 @@
         <p:spPr>
           <a:xfrm>
             <a:off x="335520" y="764640"/>
-            <a:ext cx="10738800" cy="489600"/>
+            <a:ext cx="10738440" cy="489240"/>
           </a:xfrm>
           <a:prstGeom prst="rect">
             <a:avLst/>
@@ -14657,7 +14405,7 @@
         <p:spPr>
           <a:xfrm>
             <a:off x="335520" y="1268640"/>
-            <a:ext cx="10738800" cy="5026320"/>
+            <a:ext cx="10738440" cy="5025960"/>
           </a:xfrm>
           <a:prstGeom prst="rect">
             <a:avLst/>
@@ -15168,7 +14916,7 @@
         <p:spPr>
           <a:xfrm>
             <a:off x="335520" y="764640"/>
-            <a:ext cx="10738800" cy="489600"/>
+            <a:ext cx="10738440" cy="489240"/>
           </a:xfrm>
           <a:prstGeom prst="rect">
             <a:avLst/>
@@ -15204,7 +14952,7 @@
                 <a:latin typeface="DejaVu Sans"/>
                 <a:ea typeface="DejaVu Sans"/>
               </a:rPr>
-              <a:t>Exercises</a:t>
+              <a:t>Exercise Deadlines</a:t>
             </a:r>
             <a:endParaRPr lang="en-US" sz="2400" b="0" u="none" strike="noStrike">
               <a:solidFill>
@@ -15226,7 +14974,7 @@
         <p:spPr>
           <a:xfrm>
             <a:off x="335520" y="1268640"/>
-            <a:ext cx="10738800" cy="5026320"/>
+            <a:ext cx="10738440" cy="5025960"/>
           </a:xfrm>
           <a:prstGeom prst="rect">
             <a:avLst/>
@@ -15271,7 +15019,7 @@
                 <a:latin typeface="DejaVu Sans"/>
                 <a:ea typeface="DejaVu Sans"/>
               </a:rPr>
-              <a:t>04.05.2026 </a:t>
+              <a:t>11.05.2026 </a:t>
             </a:r>
             <a:r>
               <a:rPr lang="en-US" sz="1800" b="0" u="none" strike="noStrike">
@@ -15331,19 +15079,7 @@
                 <a:latin typeface="DejaVu Sans"/>
                 <a:ea typeface="DejaVu Sans"/>
               </a:rPr>
-              <a:t>11.05.2026</a:t>
-            </a:r>
-            <a:r>
-              <a:rPr lang="de-DE" sz="1800" b="0" u="none" strike="noStrike">
-                <a:solidFill>
-                  <a:srgbClr val="000000"/>
-                </a:solidFill>
-                <a:effectLst/>
-                <a:uFillTx/>
-                <a:latin typeface="DejaVu Sans"/>
-                <a:ea typeface="DejaVu Sans"/>
-              </a:rPr>
-              <a:t> </a:t>
+              <a:t>18.05.2026 </a:t>
             </a:r>
             <a:r>
               <a:rPr lang="en-US" sz="1800" b="0" u="none" strike="noStrike">
@@ -15403,7 +15139,7 @@
                 <a:latin typeface="DejaVu Sans"/>
                 <a:ea typeface="DejaVu Sans"/>
               </a:rPr>
-              <a:t>18.05.2026 </a:t>
+              <a:t>01.06.2026 </a:t>
             </a:r>
             <a:r>
               <a:rPr lang="en-US" sz="1800" b="0" u="none" strike="noStrike">
@@ -15463,7 +15199,7 @@
                 <a:latin typeface="DejaVu Sans"/>
                 <a:ea typeface="DejaVu Sans"/>
               </a:rPr>
-              <a:t>25.05.2026 </a:t>
+              <a:t>08.06.2026 </a:t>
             </a:r>
             <a:r>
               <a:rPr lang="en-US" sz="1800" b="0" u="none" strike="noStrike">
@@ -15523,7 +15259,7 @@
                 <a:latin typeface="DejaVu Sans"/>
                 <a:ea typeface="DejaVu Sans"/>
               </a:rPr>
-              <a:t>01.06.2026 </a:t>
+              <a:t>15.06.2026 </a:t>
             </a:r>
             <a:r>
               <a:rPr lang="en-US" sz="1800" b="0" u="none" strike="noStrike">
@@ -15583,7 +15319,7 @@
                 <a:latin typeface="DejaVu Sans"/>
                 <a:ea typeface="DejaVu Sans"/>
               </a:rPr>
-              <a:t>08.06.2026 </a:t>
+              <a:t>22.06.2026 </a:t>
             </a:r>
             <a:r>
               <a:rPr lang="en-US" sz="1800" b="0" u="none" strike="noStrike">
@@ -15643,7 +15379,7 @@
                 <a:latin typeface="DejaVu Sans"/>
                 <a:ea typeface="DejaVu Sans"/>
               </a:rPr>
-              <a:t>15.06.2026 </a:t>
+              <a:t>29.06.2026 </a:t>
             </a:r>
             <a:r>
               <a:rPr lang="en-US" sz="1800" b="0" u="none" strike="noStrike">
@@ -15703,7 +15439,7 @@
                 <a:latin typeface="DejaVu Sans"/>
                 <a:ea typeface="DejaVu Sans"/>
               </a:rPr>
-              <a:t>22.06.2026 → Exercise 08 – TBA</a:t>
+              <a:t>06.07.2026 → Exercise 08 – TBA</a:t>
             </a:r>
             <a:endParaRPr lang="en-US" sz="1800" b="0" u="none" strike="noStrike">
               <a:solidFill>
@@ -15739,7 +15475,7 @@
                 <a:latin typeface="DejaVu Sans"/>
                 <a:ea typeface="DejaVu Sans"/>
               </a:rPr>
-              <a:t>29.06.2026 → Exercise 09 – TBA</a:t>
+              <a:t>13.07.2026 → Exercise 09 – TBA</a:t>
             </a:r>
             <a:endParaRPr lang="en-US" sz="1800" b="0" u="none" strike="noStrike">
               <a:solidFill>
@@ -15775,7 +15511,7 @@
                 <a:latin typeface="DejaVu Sans"/>
                 <a:ea typeface="DejaVu Sans"/>
               </a:rPr>
-              <a:t>06.07.2026 → Exercise 10 – TBA</a:t>
+              <a:t>20.07.2026 → Exercise 10 – TBA</a:t>
             </a:r>
             <a:endParaRPr lang="en-US" sz="1800" b="0" u="none" strike="noStrike">
               <a:solidFill>

</xml_diff>

<commit_message>
Update deadline slide title
</commit_message>
<xml_diff>
--- a/Emerging-Technologies-for-the-Circular-Economy/ETCE-L00-Organization.pptx
+++ b/Emerging-Technologies-for-the-Circular-Economy/ETCE-L00-Organization.pptx
@@ -398,7 +398,7 @@
             <a:pPr indent="0" algn="r">
               <a:buNone/>
             </a:pPr>
-            <a:fld id="{0C4E021F-0DC6-41A5-9DDC-447EAB13DB95}" type="slidenum">
+            <a:fld id="{0D836A76-16D0-4805-9E3A-B92640A35110}" type="slidenum">
               <a:rPr lang="en-US" sz="1400" b="0" u="none" strike="noStrike">
                 <a:solidFill>
                   <a:srgbClr val="000000"/>
@@ -456,7 +456,7 @@
         <p:spPr>
           <a:xfrm>
             <a:off x="533520" y="763560"/>
-            <a:ext cx="6685920" cy="3754080"/>
+            <a:ext cx="6685560" cy="3753720"/>
           </a:xfrm>
           <a:prstGeom prst="rect">
             <a:avLst/>
@@ -479,7 +479,7 @@
         <p:spPr>
           <a:xfrm>
             <a:off x="777240" y="4777560"/>
-            <a:ext cx="6199560" cy="4507920"/>
+            <a:ext cx="6199200" cy="4507560"/>
           </a:xfrm>
           <a:prstGeom prst="rect">
             <a:avLst/>
@@ -517,7 +517,7 @@
         <p:spPr>
           <a:xfrm>
             <a:off x="4399200" y="9555480"/>
-            <a:ext cx="3354840" cy="484560"/>
+            <a:ext cx="3354480" cy="484200"/>
           </a:xfrm>
           <a:prstGeom prst="rect">
             <a:avLst/>
@@ -543,7 +543,7 @@
                 <a:spcPct val="100000"/>
               </a:lnSpc>
             </a:pPr>
-            <a:fld id="{C9A34377-79F7-43B6-B771-A25990933F4F}" type="slidenum">
+            <a:fld id="{0D40A4AC-0372-4FA0-AF98-28FC6F22663E}" type="slidenum">
               <a:rPr lang="de-DE" sz="1800" b="0" u="none" strike="noStrike">
                 <a:solidFill>
                   <a:srgbClr val="000000"/>
@@ -553,7 +553,7 @@
                 <a:latin typeface="+mn-lt"/>
                 <a:ea typeface="+mn-ea"/>
               </a:rPr>
-              <a:t>6</a:t>
+              <a:t>&lt;number&gt;</a:t>
             </a:fld>
             <a:endParaRPr lang="en-US" sz="1800" b="0" u="none" strike="noStrike">
               <a:solidFill>
@@ -601,7 +601,7 @@
         <p:spPr>
           <a:xfrm>
             <a:off x="533520" y="763560"/>
-            <a:ext cx="6685920" cy="3754080"/>
+            <a:ext cx="6685560" cy="3753720"/>
           </a:xfrm>
           <a:prstGeom prst="rect">
             <a:avLst/>
@@ -624,7 +624,7 @@
         <p:spPr>
           <a:xfrm>
             <a:off x="777240" y="4777560"/>
-            <a:ext cx="6199560" cy="4507920"/>
+            <a:ext cx="6199200" cy="4507560"/>
           </a:xfrm>
           <a:prstGeom prst="rect">
             <a:avLst/>
@@ -662,7 +662,7 @@
         <p:spPr>
           <a:xfrm>
             <a:off x="4399200" y="9555480"/>
-            <a:ext cx="3354840" cy="484560"/>
+            <a:ext cx="3354480" cy="484200"/>
           </a:xfrm>
           <a:prstGeom prst="rect">
             <a:avLst/>
@@ -688,7 +688,7 @@
                 <a:spcPct val="100000"/>
               </a:lnSpc>
             </a:pPr>
-            <a:fld id="{24E2D19B-3E56-4A53-BEF3-D92E263EAD02}" type="slidenum">
+            <a:fld id="{0DD80586-B625-4B60-A442-EBF77632FB18}" type="slidenum">
               <a:rPr lang="de-DE" sz="1800" b="0" u="none" strike="noStrike">
                 <a:solidFill>
                   <a:srgbClr val="000000"/>
@@ -698,7 +698,7 @@
                 <a:latin typeface="+mn-lt"/>
                 <a:ea typeface="+mn-ea"/>
               </a:rPr>
-              <a:t>6</a:t>
+              <a:t>&lt;number&gt;</a:t>
             </a:fld>
             <a:endParaRPr lang="en-US" sz="1800" b="0" u="none" strike="noStrike">
               <a:solidFill>
@@ -746,7 +746,7 @@
         <p:spPr>
           <a:xfrm>
             <a:off x="533520" y="763560"/>
-            <a:ext cx="6685920" cy="3754080"/>
+            <a:ext cx="6685560" cy="3753720"/>
           </a:xfrm>
           <a:prstGeom prst="rect">
             <a:avLst/>
@@ -769,7 +769,7 @@
         <p:spPr>
           <a:xfrm>
             <a:off x="777240" y="4777560"/>
-            <a:ext cx="6199560" cy="4507920"/>
+            <a:ext cx="6199200" cy="4507560"/>
           </a:xfrm>
           <a:prstGeom prst="rect">
             <a:avLst/>
@@ -807,7 +807,7 @@
         <p:spPr>
           <a:xfrm>
             <a:off x="4399200" y="9555480"/>
-            <a:ext cx="3354840" cy="484560"/>
+            <a:ext cx="3354480" cy="484200"/>
           </a:xfrm>
           <a:prstGeom prst="rect">
             <a:avLst/>
@@ -833,7 +833,7 @@
                 <a:spcPct val="100000"/>
               </a:lnSpc>
             </a:pPr>
-            <a:fld id="{56801E0E-BEC0-406A-8658-DE8ADE853C03}" type="slidenum">
+            <a:fld id="{54DFABAE-9F00-42E0-A0EB-3F4D370E7516}" type="slidenum">
               <a:rPr lang="de-DE" sz="1800" b="0" u="none" strike="noStrike">
                 <a:solidFill>
                   <a:srgbClr val="000000"/>
@@ -843,7 +843,7 @@
                 <a:latin typeface="+mn-lt"/>
                 <a:ea typeface="+mn-ea"/>
               </a:rPr>
-              <a:t>6</a:t>
+              <a:t>&lt;number&gt;</a:t>
             </a:fld>
             <a:endParaRPr lang="en-US" sz="1800" b="0" u="none" strike="noStrike">
               <a:solidFill>
@@ -938,7 +938,7 @@
         <p:spPr>
           <a:xfrm>
             <a:off x="11444760" y="0"/>
-            <a:ext cx="734400" cy="6843240"/>
+            <a:ext cx="734040" cy="6842880"/>
           </a:xfrm>
           <a:prstGeom prst="rect">
             <a:avLst/>
@@ -983,7 +983,7 @@
         <p:spPr>
           <a:xfrm>
             <a:off x="11438640" y="6453360"/>
-            <a:ext cx="751320" cy="363960"/>
+            <a:ext cx="750960" cy="363960"/>
           </a:xfrm>
           <a:prstGeom prst="rect">
             <a:avLst/>
@@ -1009,7 +1009,7 @@
                 <a:spcPct val="100000"/>
               </a:lnSpc>
             </a:pPr>
-            <a:fld id="{2116B04D-B101-4370-8F3A-853A6966F364}" type="slidenum">
+            <a:fld id="{F3DE66F9-D69E-4BDD-96B5-110D2F844C29}" type="slidenum">
               <a:rPr lang="en-US" sz="1800" b="0" u="none" strike="noStrike">
                 <a:solidFill>
                   <a:srgbClr val="808080"/>
@@ -1019,7 +1019,7 @@
                 <a:latin typeface="Arial"/>
                 <a:ea typeface="DejaVu Sans"/>
               </a:rPr>
-              <a:t>&lt;number&gt;</a:t>
+              <a:t>9</a:t>
             </a:fld>
             <a:endParaRPr lang="en-US" sz="1800" b="0" u="none" strike="noStrike">
               <a:solidFill>
@@ -1041,7 +1041,7 @@
         <p:spPr>
           <a:xfrm>
             <a:off x="912240" y="1268280"/>
-            <a:ext cx="9201240" cy="354600"/>
+            <a:ext cx="9200880" cy="354240"/>
           </a:xfrm>
           <a:prstGeom prst="rect">
             <a:avLst/>
@@ -1086,7 +1086,7 @@
         <p:spPr>
           <a:xfrm>
             <a:off x="0" y="0"/>
-            <a:ext cx="3045240" cy="555120"/>
+            <a:ext cx="3044880" cy="554760"/>
           </a:xfrm>
           <a:prstGeom prst="rect">
             <a:avLst/>
@@ -1110,7 +1110,7 @@
         <p:spPr>
           <a:xfrm>
             <a:off x="7430400" y="134640"/>
-            <a:ext cx="3691080" cy="507240"/>
+            <a:ext cx="3690720" cy="506880"/>
           </a:xfrm>
           <a:prstGeom prst="rect">
             <a:avLst/>
@@ -1130,7 +1130,7 @@
         <p:spPr>
           <a:xfrm>
             <a:off x="912240" y="1268280"/>
-            <a:ext cx="9201240" cy="354600"/>
+            <a:ext cx="9200880" cy="354240"/>
           </a:xfrm>
           <a:prstGeom prst="rect">
             <a:avLst/>
@@ -1171,7 +1171,7 @@
         <p:spPr>
           <a:xfrm>
             <a:off x="11444760" y="0"/>
-            <a:ext cx="734400" cy="6843240"/>
+            <a:ext cx="734040" cy="6842880"/>
           </a:xfrm>
           <a:prstGeom prst="rect">
             <a:avLst/>
@@ -1216,7 +1216,7 @@
         <p:spPr>
           <a:xfrm>
             <a:off x="0" y="6642720"/>
-            <a:ext cx="12177360" cy="211320"/>
+            <a:ext cx="12177000" cy="211320"/>
           </a:xfrm>
           <a:prstGeom prst="rect">
             <a:avLst/>
@@ -1723,7 +1723,7 @@
         <p:spPr>
           <a:xfrm>
             <a:off x="11444760" y="0"/>
-            <a:ext cx="734400" cy="6843240"/>
+            <a:ext cx="734040" cy="6842880"/>
           </a:xfrm>
           <a:prstGeom prst="rect">
             <a:avLst/>
@@ -1768,7 +1768,7 @@
         <p:spPr>
           <a:xfrm>
             <a:off x="11438640" y="6453360"/>
-            <a:ext cx="751320" cy="363960"/>
+            <a:ext cx="750960" cy="363960"/>
           </a:xfrm>
           <a:prstGeom prst="rect">
             <a:avLst/>
@@ -1794,7 +1794,7 @@
                 <a:spcPct val="100000"/>
               </a:lnSpc>
             </a:pPr>
-            <a:fld id="{2DB44041-47ED-4434-BAAA-AB31F9FF40D3}" type="slidenum">
+            <a:fld id="{BE17FC44-5FB6-4EC4-A4B3-CEBCC7B83E4E}" type="slidenum">
               <a:rPr lang="en-US" sz="1800" b="0" u="none" strike="noStrike">
                 <a:solidFill>
                   <a:srgbClr val="808080"/>
@@ -1826,7 +1826,7 @@
         <p:spPr>
           <a:xfrm>
             <a:off x="912240" y="1268280"/>
-            <a:ext cx="9201240" cy="354600"/>
+            <a:ext cx="9200880" cy="354240"/>
           </a:xfrm>
           <a:prstGeom prst="rect">
             <a:avLst/>
@@ -1871,7 +1871,7 @@
         <p:spPr>
           <a:xfrm>
             <a:off x="0" y="0"/>
-            <a:ext cx="3045240" cy="555120"/>
+            <a:ext cx="3044880" cy="554760"/>
           </a:xfrm>
           <a:prstGeom prst="rect">
             <a:avLst/>
@@ -1895,7 +1895,7 @@
         <p:spPr>
           <a:xfrm>
             <a:off x="7430400" y="134640"/>
-            <a:ext cx="3691080" cy="507240"/>
+            <a:ext cx="3690720" cy="506880"/>
           </a:xfrm>
           <a:prstGeom prst="rect">
             <a:avLst/>
@@ -1915,7 +1915,7 @@
         <p:spPr>
           <a:xfrm>
             <a:off x="11444760" y="0"/>
-            <a:ext cx="734400" cy="6843240"/>
+            <a:ext cx="734040" cy="6842880"/>
           </a:xfrm>
           <a:prstGeom prst="rect">
             <a:avLst/>
@@ -1960,7 +1960,7 @@
         <p:spPr>
           <a:xfrm>
             <a:off x="11438640" y="6453360"/>
-            <a:ext cx="751320" cy="363960"/>
+            <a:ext cx="750960" cy="363960"/>
           </a:xfrm>
           <a:prstGeom prst="rect">
             <a:avLst/>
@@ -1986,7 +1986,7 @@
                 <a:spcPct val="100000"/>
               </a:lnSpc>
             </a:pPr>
-            <a:fld id="{D371301A-A820-4D81-9DBA-640B3FACFD6B}" type="slidenum">
+            <a:fld id="{A3743244-226C-4120-BA35-4AA26D2F2CA6}" type="slidenum">
               <a:rPr lang="en-US" sz="1800" b="0" u="none" strike="noStrike">
                 <a:solidFill>
                   <a:srgbClr val="808080"/>
@@ -2018,7 +2018,7 @@
         <p:spPr>
           <a:xfrm>
             <a:off x="0" y="6642720"/>
-            <a:ext cx="12177360" cy="211320"/>
+            <a:ext cx="12177000" cy="211320"/>
           </a:xfrm>
           <a:prstGeom prst="rect">
             <a:avLst/>
@@ -2518,7 +2518,7 @@
         <p:spPr>
           <a:xfrm>
             <a:off x="527400" y="1412640"/>
-            <a:ext cx="10354320" cy="1140840"/>
+            <a:ext cx="10353960" cy="1140480"/>
           </a:xfrm>
           <a:prstGeom prst="rect">
             <a:avLst/>
@@ -2576,7 +2576,7 @@
         <p:spPr>
           <a:xfrm>
             <a:off x="527400" y="2852640"/>
-            <a:ext cx="10354320" cy="2361600"/>
+            <a:ext cx="10353960" cy="2361240"/>
           </a:xfrm>
           <a:prstGeom prst="rect">
             <a:avLst/>
@@ -2832,7 +2832,7 @@
         <p:spPr>
           <a:xfrm>
             <a:off x="335520" y="764640"/>
-            <a:ext cx="10738440" cy="489240"/>
+            <a:ext cx="10738080" cy="488880"/>
           </a:xfrm>
           <a:prstGeom prst="rect">
             <a:avLst/>
@@ -2890,7 +2890,7 @@
         <p:spPr>
           <a:xfrm>
             <a:off x="335520" y="1268280"/>
-            <a:ext cx="10738440" cy="5025960"/>
+            <a:ext cx="10738080" cy="5025600"/>
           </a:xfrm>
           <a:prstGeom prst="rect">
             <a:avLst/>
@@ -3372,7 +3372,7 @@
         <p:spPr>
           <a:xfrm>
             <a:off x="335520" y="764640"/>
-            <a:ext cx="10737000" cy="487800"/>
+            <a:ext cx="10736640" cy="487440"/>
           </a:xfrm>
           <a:prstGeom prst="rect">
             <a:avLst/>
@@ -3460,7 +3460,7 @@
         <p:spPr>
           <a:xfrm>
             <a:off x="335520" y="1268640"/>
-            <a:ext cx="10737000" cy="5024520"/>
+            <a:ext cx="10736640" cy="5024160"/>
           </a:xfrm>
           <a:prstGeom prst="rect">
             <a:avLst/>
@@ -3943,7 +3943,7 @@
         <p:spPr>
           <a:xfrm>
             <a:off x="335520" y="764640"/>
-            <a:ext cx="10738440" cy="489240"/>
+            <a:ext cx="10738080" cy="488880"/>
           </a:xfrm>
           <a:prstGeom prst="rect">
             <a:avLst/>
@@ -4001,7 +4001,7 @@
         <p:spPr>
           <a:xfrm>
             <a:off x="335520" y="1268280"/>
-            <a:ext cx="10738440" cy="5025960"/>
+            <a:ext cx="10738080" cy="5025600"/>
           </a:xfrm>
           <a:prstGeom prst="rect">
             <a:avLst/>
@@ -4485,7 +4485,7 @@
         <p:spPr>
           <a:xfrm>
             <a:off x="335520" y="764640"/>
-            <a:ext cx="10738440" cy="489240"/>
+            <a:ext cx="10738080" cy="488880"/>
           </a:xfrm>
           <a:prstGeom prst="rect">
             <a:avLst/>
@@ -4543,7 +4543,7 @@
         <p:spPr>
           <a:xfrm>
             <a:off x="335520" y="1600200"/>
-            <a:ext cx="4464720" cy="4694400"/>
+            <a:ext cx="4464360" cy="4694040"/>
           </a:xfrm>
           <a:prstGeom prst="rect">
             <a:avLst/>
@@ -4714,7 +4714,7 @@
         <p:spPr>
           <a:xfrm>
             <a:off x="4655880" y="476640"/>
-            <a:ext cx="2424600" cy="350640"/>
+            <a:ext cx="2424240" cy="350280"/>
           </a:xfrm>
           <a:prstGeom prst="rect">
             <a:avLst/>
@@ -4759,7 +4759,7 @@
         <p:spPr>
           <a:xfrm>
             <a:off x="5715000" y="1448280"/>
-            <a:ext cx="4857120" cy="4759920"/>
+            <a:ext cx="4856760" cy="4759560"/>
           </a:xfrm>
           <a:prstGeom prst="rect">
             <a:avLst/>
@@ -4809,7 +4809,7 @@
         <p:spPr>
           <a:xfrm>
             <a:off x="335520" y="764640"/>
-            <a:ext cx="10738440" cy="489240"/>
+            <a:ext cx="10738080" cy="488880"/>
           </a:xfrm>
           <a:prstGeom prst="rect">
             <a:avLst/>
@@ -4867,7 +4867,7 @@
         <p:spPr>
           <a:xfrm>
             <a:off x="335520" y="1600200"/>
-            <a:ext cx="4464720" cy="4694400"/>
+            <a:ext cx="4464360" cy="4694040"/>
           </a:xfrm>
           <a:prstGeom prst="rect">
             <a:avLst/>
@@ -4969,7 +4969,7 @@
         <p:spPr>
           <a:xfrm>
             <a:off x="4655880" y="476640"/>
-            <a:ext cx="2424600" cy="350640"/>
+            <a:ext cx="2424240" cy="350280"/>
           </a:xfrm>
           <a:prstGeom prst="rect">
             <a:avLst/>
@@ -5014,7 +5014,7 @@
         <p:spPr>
           <a:xfrm>
             <a:off x="5715000" y="1448280"/>
-            <a:ext cx="4857120" cy="4759920"/>
+            <a:ext cx="4856760" cy="4759560"/>
           </a:xfrm>
           <a:prstGeom prst="rect">
             <a:avLst/>
@@ -5034,7 +5034,7 @@
         <p:spPr>
           <a:xfrm>
             <a:off x="5943600" y="5535000"/>
-            <a:ext cx="456840" cy="228240"/>
+            <a:ext cx="456480" cy="227880"/>
           </a:xfrm>
           <a:prstGeom prst="rightArrow">
             <a:avLst>
@@ -5112,7 +5112,7 @@
         <p:spPr>
           <a:xfrm>
             <a:off x="335520" y="764640"/>
-            <a:ext cx="10738440" cy="489240"/>
+            <a:ext cx="10738080" cy="488880"/>
           </a:xfrm>
           <a:prstGeom prst="rect">
             <a:avLst/>
@@ -5170,7 +5170,7 @@
         <p:spPr>
           <a:xfrm>
             <a:off x="335520" y="1600200"/>
-            <a:ext cx="4464720" cy="4694400"/>
+            <a:ext cx="4464360" cy="4694040"/>
           </a:xfrm>
           <a:prstGeom prst="rect">
             <a:avLst/>
@@ -5307,7 +5307,7 @@
         <p:spPr>
           <a:xfrm>
             <a:off x="4655880" y="476640"/>
-            <a:ext cx="2424600" cy="350640"/>
+            <a:ext cx="2424240" cy="350280"/>
           </a:xfrm>
           <a:prstGeom prst="rect">
             <a:avLst/>
@@ -5353,7 +5353,7 @@
         <p:spPr>
           <a:xfrm>
             <a:off x="5785920" y="1484280"/>
-            <a:ext cx="5293080" cy="4001760"/>
+            <a:ext cx="5292720" cy="4001400"/>
           </a:xfrm>
           <a:prstGeom prst="rect">
             <a:avLst/>
@@ -5373,7 +5373,7 @@
         <p:spPr>
           <a:xfrm>
             <a:off x="5680800" y="4343400"/>
-            <a:ext cx="456840" cy="228240"/>
+            <a:ext cx="456480" cy="227880"/>
           </a:xfrm>
           <a:prstGeom prst="rightArrow">
             <a:avLst>
@@ -5451,7 +5451,7 @@
         <p:spPr>
           <a:xfrm>
             <a:off x="335520" y="764640"/>
-            <a:ext cx="10738440" cy="489240"/>
+            <a:ext cx="10738080" cy="488880"/>
           </a:xfrm>
           <a:prstGeom prst="rect">
             <a:avLst/>
@@ -5509,7 +5509,7 @@
         <p:spPr>
           <a:xfrm>
             <a:off x="335520" y="1600200"/>
-            <a:ext cx="4464720" cy="4694400"/>
+            <a:ext cx="4464360" cy="4694040"/>
           </a:xfrm>
           <a:prstGeom prst="rect">
             <a:avLst/>
@@ -5681,7 +5681,7 @@
         <p:spPr>
           <a:xfrm>
             <a:off x="4655880" y="476640"/>
-            <a:ext cx="2424600" cy="350640"/>
+            <a:ext cx="2424240" cy="350280"/>
           </a:xfrm>
           <a:prstGeom prst="rect">
             <a:avLst/>
@@ -5727,7 +5727,7 @@
         <p:spPr>
           <a:xfrm>
             <a:off x="6172200" y="1600200"/>
-            <a:ext cx="4876200" cy="4263840"/>
+            <a:ext cx="4875840" cy="4263480"/>
           </a:xfrm>
           <a:prstGeom prst="rect">
             <a:avLst/>
@@ -5747,7 +5747,7 @@
         <p:spPr>
           <a:xfrm>
             <a:off x="6172200" y="4716000"/>
-            <a:ext cx="456840" cy="228240"/>
+            <a:ext cx="456480" cy="227880"/>
           </a:xfrm>
           <a:prstGeom prst="rightArrow">
             <a:avLst>
@@ -5825,7 +5825,7 @@
         <p:spPr>
           <a:xfrm>
             <a:off x="335520" y="764640"/>
-            <a:ext cx="10738440" cy="489240"/>
+            <a:ext cx="10738080" cy="488880"/>
           </a:xfrm>
           <a:prstGeom prst="rect">
             <a:avLst/>
@@ -5883,7 +5883,7 @@
         <p:spPr>
           <a:xfrm>
             <a:off x="335520" y="1600200"/>
-            <a:ext cx="4464720" cy="4694400"/>
+            <a:ext cx="4464360" cy="4694040"/>
           </a:xfrm>
           <a:prstGeom prst="rect">
             <a:avLst/>
@@ -6090,7 +6090,7 @@
         <p:spPr>
           <a:xfrm>
             <a:off x="4655880" y="476640"/>
-            <a:ext cx="2424600" cy="350640"/>
+            <a:ext cx="2424240" cy="350280"/>
           </a:xfrm>
           <a:prstGeom prst="rect">
             <a:avLst/>
@@ -6135,7 +6135,7 @@
         <p:spPr>
           <a:xfrm>
             <a:off x="6172200" y="1600200"/>
-            <a:ext cx="4343040" cy="4619880"/>
+            <a:ext cx="4342680" cy="4619520"/>
           </a:xfrm>
           <a:prstGeom prst="rect">
             <a:avLst/>
@@ -6185,7 +6185,7 @@
         <p:spPr>
           <a:xfrm>
             <a:off x="335520" y="764640"/>
-            <a:ext cx="10738440" cy="489240"/>
+            <a:ext cx="10738080" cy="488880"/>
           </a:xfrm>
           <a:prstGeom prst="rect">
             <a:avLst/>
@@ -6243,7 +6243,7 @@
         <p:spPr>
           <a:xfrm>
             <a:off x="335520" y="1600200"/>
-            <a:ext cx="10408320" cy="2742840"/>
+            <a:ext cx="10407960" cy="2742480"/>
           </a:xfrm>
           <a:prstGeom prst="rect">
             <a:avLst/>
@@ -6345,7 +6345,7 @@
         <p:spPr>
           <a:xfrm>
             <a:off x="4655880" y="476640"/>
-            <a:ext cx="2424600" cy="350640"/>
+            <a:ext cx="2424240" cy="350280"/>
           </a:xfrm>
           <a:prstGeom prst="rect">
             <a:avLst/>
@@ -6385,13 +6385,13 @@
         </p:nvPicPr>
         <p:blipFill>
           <a:blip r:embed="rId1"/>
-          <a:srcRect l="0" t="0" r="16551" b="0"/>
+          <a:srcRect l="0" t="0" r="16549" b="0"/>
           <a:stretch/>
         </p:blipFill>
         <p:spPr>
           <a:xfrm>
             <a:off x="1067400" y="4343400"/>
-            <a:ext cx="9219240" cy="1962000"/>
+            <a:ext cx="9218880" cy="1961640"/>
           </a:xfrm>
           <a:prstGeom prst="rect">
             <a:avLst/>
@@ -6441,7 +6441,7 @@
         <p:spPr>
           <a:xfrm>
             <a:off x="335520" y="764640"/>
-            <a:ext cx="10738440" cy="489240"/>
+            <a:ext cx="10738080" cy="488880"/>
           </a:xfrm>
           <a:prstGeom prst="rect">
             <a:avLst/>
@@ -6499,7 +6499,7 @@
         <p:spPr>
           <a:xfrm>
             <a:off x="335520" y="1600200"/>
-            <a:ext cx="10408320" cy="2742840"/>
+            <a:ext cx="10407960" cy="2742480"/>
           </a:xfrm>
           <a:prstGeom prst="rect">
             <a:avLst/>
@@ -6636,7 +6636,7 @@
         <p:spPr>
           <a:xfrm>
             <a:off x="4655880" y="476640"/>
-            <a:ext cx="2424600" cy="350640"/>
+            <a:ext cx="2424240" cy="350280"/>
           </a:xfrm>
           <a:prstGeom prst="rect">
             <a:avLst/>
@@ -6681,7 +6681,7 @@
         <p:spPr>
           <a:xfrm>
             <a:off x="2057400" y="3657600"/>
-            <a:ext cx="6495480" cy="2685240"/>
+            <a:ext cx="6495120" cy="2684880"/>
           </a:xfrm>
           <a:prstGeom prst="rect">
             <a:avLst/>
@@ -6731,7 +6731,7 @@
         <p:spPr>
           <a:xfrm>
             <a:off x="335520" y="764640"/>
-            <a:ext cx="10736280" cy="487080"/>
+            <a:ext cx="10735920" cy="486720"/>
           </a:xfrm>
           <a:prstGeom prst="rect">
             <a:avLst/>
@@ -6789,7 +6789,7 @@
         <p:spPr>
           <a:xfrm>
             <a:off x="335520" y="1268640"/>
-            <a:ext cx="10736280" cy="5023800"/>
+            <a:ext cx="10735920" cy="5023440"/>
           </a:xfrm>
           <a:prstGeom prst="rect">
             <a:avLst/>
@@ -6830,7 +6830,7 @@
         <p:spPr>
           <a:xfrm>
             <a:off x="336600" y="3429000"/>
-            <a:ext cx="10854000" cy="2045880"/>
+            <a:ext cx="10853640" cy="2045520"/>
           </a:xfrm>
           <a:prstGeom prst="rect">
             <a:avLst/>
@@ -7043,7 +7043,7 @@
         <p:spPr>
           <a:xfrm>
             <a:off x="335520" y="764640"/>
-            <a:ext cx="10738440" cy="489240"/>
+            <a:ext cx="10738080" cy="488880"/>
           </a:xfrm>
           <a:prstGeom prst="rect">
             <a:avLst/>
@@ -7101,7 +7101,7 @@
         <p:spPr>
           <a:xfrm>
             <a:off x="335520" y="1600200"/>
-            <a:ext cx="10408320" cy="2742840"/>
+            <a:ext cx="10407960" cy="2742480"/>
           </a:xfrm>
           <a:prstGeom prst="rect">
             <a:avLst/>
@@ -7273,7 +7273,7 @@
         <p:spPr>
           <a:xfrm>
             <a:off x="4655880" y="476640"/>
-            <a:ext cx="2424600" cy="350640"/>
+            <a:ext cx="2424240" cy="350280"/>
           </a:xfrm>
           <a:prstGeom prst="rect">
             <a:avLst/>
@@ -7318,7 +7318,7 @@
         <p:spPr>
           <a:xfrm>
             <a:off x="2124360" y="3706200"/>
-            <a:ext cx="5876280" cy="2694240"/>
+            <a:ext cx="5875920" cy="2693880"/>
           </a:xfrm>
           <a:prstGeom prst="rect">
             <a:avLst/>
@@ -7368,7 +7368,7 @@
         <p:spPr>
           <a:xfrm>
             <a:off x="335520" y="764640"/>
-            <a:ext cx="10738440" cy="489240"/>
+            <a:ext cx="10738080" cy="488880"/>
           </a:xfrm>
           <a:prstGeom prst="rect">
             <a:avLst/>
@@ -7426,7 +7426,7 @@
         <p:spPr>
           <a:xfrm>
             <a:off x="335520" y="1600200"/>
-            <a:ext cx="10408320" cy="2742840"/>
+            <a:ext cx="10407960" cy="2742480"/>
           </a:xfrm>
           <a:prstGeom prst="rect">
             <a:avLst/>
@@ -7598,7 +7598,7 @@
         <p:spPr>
           <a:xfrm>
             <a:off x="4655880" y="476640"/>
-            <a:ext cx="2424600" cy="350640"/>
+            <a:ext cx="2424240" cy="350280"/>
           </a:xfrm>
           <a:prstGeom prst="rect">
             <a:avLst/>
@@ -7638,13 +7638,13 @@
         </p:nvPicPr>
         <p:blipFill>
           <a:blip r:embed="rId1"/>
-          <a:srcRect l="0" t="24691" r="0" b="0"/>
+          <a:srcRect l="0" t="24687" r="0" b="0"/>
           <a:stretch/>
         </p:blipFill>
         <p:spPr>
           <a:xfrm>
             <a:off x="5063400" y="3056400"/>
-            <a:ext cx="5656320" cy="3656880"/>
+            <a:ext cx="5655960" cy="3656520"/>
           </a:xfrm>
           <a:prstGeom prst="rect">
             <a:avLst/>
@@ -7694,7 +7694,7 @@
         <p:spPr>
           <a:xfrm>
             <a:off x="335520" y="764640"/>
-            <a:ext cx="10738440" cy="489240"/>
+            <a:ext cx="10738080" cy="488880"/>
           </a:xfrm>
           <a:prstGeom prst="rect">
             <a:avLst/>
@@ -7752,7 +7752,7 @@
         <p:spPr>
           <a:xfrm>
             <a:off x="335520" y="1600200"/>
-            <a:ext cx="10408320" cy="2742840"/>
+            <a:ext cx="10407960" cy="2742480"/>
           </a:xfrm>
           <a:prstGeom prst="rect">
             <a:avLst/>
@@ -7945,7 +7945,7 @@
         <p:spPr>
           <a:xfrm>
             <a:off x="4655880" y="476640"/>
-            <a:ext cx="2424600" cy="350640"/>
+            <a:ext cx="2424240" cy="350280"/>
           </a:xfrm>
           <a:prstGeom prst="rect">
             <a:avLst/>
@@ -8016,7 +8016,7 @@
         <p:spPr>
           <a:xfrm>
             <a:off x="335520" y="764640"/>
-            <a:ext cx="10738440" cy="489240"/>
+            <a:ext cx="10738080" cy="488880"/>
           </a:xfrm>
           <a:prstGeom prst="rect">
             <a:avLst/>
@@ -8074,7 +8074,7 @@
         <p:spPr>
           <a:xfrm>
             <a:off x="335520" y="1600200"/>
-            <a:ext cx="10408320" cy="2742840"/>
+            <a:ext cx="10407960" cy="2742480"/>
           </a:xfrm>
           <a:prstGeom prst="rect">
             <a:avLst/>
@@ -8303,7 +8303,7 @@
         <p:spPr>
           <a:xfrm>
             <a:off x="4655880" y="476640"/>
-            <a:ext cx="2424600" cy="350640"/>
+            <a:ext cx="2424240" cy="350280"/>
           </a:xfrm>
           <a:prstGeom prst="rect">
             <a:avLst/>
@@ -8348,7 +8348,7 @@
         <p:spPr>
           <a:xfrm>
             <a:off x="2372040" y="3657600"/>
-            <a:ext cx="7228800" cy="2856960"/>
+            <a:ext cx="7228440" cy="2856600"/>
           </a:xfrm>
           <a:prstGeom prst="rect">
             <a:avLst/>
@@ -8398,7 +8398,7 @@
         <p:spPr>
           <a:xfrm>
             <a:off x="335520" y="764640"/>
-            <a:ext cx="10738440" cy="489240"/>
+            <a:ext cx="10738080" cy="488880"/>
           </a:xfrm>
           <a:prstGeom prst="rect">
             <a:avLst/>
@@ -8456,7 +8456,7 @@
         <p:spPr>
           <a:xfrm>
             <a:off x="335520" y="1600200"/>
-            <a:ext cx="10408320" cy="2742840"/>
+            <a:ext cx="10407960" cy="2742480"/>
           </a:xfrm>
           <a:prstGeom prst="rect">
             <a:avLst/>
@@ -8721,7 +8721,7 @@
         <p:spPr>
           <a:xfrm>
             <a:off x="4655880" y="476640"/>
-            <a:ext cx="2424600" cy="350640"/>
+            <a:ext cx="2424240" cy="350280"/>
           </a:xfrm>
           <a:prstGeom prst="rect">
             <a:avLst/>
@@ -8766,7 +8766,7 @@
         <p:spPr>
           <a:xfrm>
             <a:off x="2971800" y="3777480"/>
-            <a:ext cx="6171840" cy="2622960"/>
+            <a:ext cx="6171480" cy="2622600"/>
           </a:xfrm>
           <a:prstGeom prst="rect">
             <a:avLst/>
@@ -8816,7 +8816,7 @@
         <p:spPr>
           <a:xfrm>
             <a:off x="335520" y="764640"/>
-            <a:ext cx="10738440" cy="489240"/>
+            <a:ext cx="10738080" cy="488880"/>
           </a:xfrm>
           <a:prstGeom prst="rect">
             <a:avLst/>
@@ -8874,7 +8874,7 @@
         <p:spPr>
           <a:xfrm>
             <a:off x="335520" y="1600200"/>
-            <a:ext cx="10408320" cy="2742840"/>
+            <a:ext cx="10407960" cy="2742480"/>
           </a:xfrm>
           <a:prstGeom prst="rect">
             <a:avLst/>
@@ -9175,7 +9175,7 @@
         <p:spPr>
           <a:xfrm>
             <a:off x="4655880" y="476640"/>
-            <a:ext cx="2424600" cy="350640"/>
+            <a:ext cx="2424240" cy="350280"/>
           </a:xfrm>
           <a:prstGeom prst="rect">
             <a:avLst/>
@@ -9246,7 +9246,7 @@
         <p:spPr>
           <a:xfrm>
             <a:off x="335520" y="768240"/>
-            <a:ext cx="10738440" cy="489240"/>
+            <a:ext cx="10738080" cy="488880"/>
           </a:xfrm>
           <a:prstGeom prst="rect">
             <a:avLst/>
@@ -9304,7 +9304,7 @@
         <p:spPr>
           <a:xfrm>
             <a:off x="388800" y="1488600"/>
-            <a:ext cx="10712160" cy="3505320"/>
+            <a:ext cx="10711800" cy="3505320"/>
           </a:xfrm>
           <a:prstGeom prst="rect">
             <a:avLst/>
@@ -9719,7 +9719,7 @@
         <p:spPr>
           <a:xfrm>
             <a:off x="335520" y="768240"/>
-            <a:ext cx="10738440" cy="489240"/>
+            <a:ext cx="10738080" cy="488880"/>
           </a:xfrm>
           <a:prstGeom prst="rect">
             <a:avLst/>
@@ -9777,7 +9777,7 @@
         <p:spPr>
           <a:xfrm>
             <a:off x="388800" y="1488600"/>
-            <a:ext cx="10712160" cy="3505320"/>
+            <a:ext cx="10711800" cy="3505320"/>
           </a:xfrm>
           <a:prstGeom prst="rect">
             <a:avLst/>
@@ -10216,7 +10216,7 @@
         <p:spPr>
           <a:xfrm>
             <a:off x="335520" y="764640"/>
-            <a:ext cx="10738440" cy="489240"/>
+            <a:ext cx="10738080" cy="488880"/>
           </a:xfrm>
           <a:prstGeom prst="rect">
             <a:avLst/>
@@ -10278,7 +10278,7 @@
         <p:spPr>
           <a:xfrm>
             <a:off x="3200400" y="685800"/>
-            <a:ext cx="5273280" cy="5997960"/>
+            <a:ext cx="5272920" cy="5997600"/>
           </a:xfrm>
           <a:prstGeom prst="rect">
             <a:avLst/>
@@ -10328,7 +10328,7 @@
         <p:spPr>
           <a:xfrm>
             <a:off x="335520" y="764640"/>
-            <a:ext cx="10738440" cy="489240"/>
+            <a:ext cx="10738080" cy="488880"/>
           </a:xfrm>
           <a:prstGeom prst="rect">
             <a:avLst/>
@@ -10390,7 +10390,7 @@
         <p:spPr>
           <a:xfrm>
             <a:off x="1600200" y="1600200"/>
-            <a:ext cx="8359560" cy="4628160"/>
+            <a:ext cx="8359200" cy="4627800"/>
           </a:xfrm>
           <a:prstGeom prst="rect">
             <a:avLst/>
@@ -10440,7 +10440,7 @@
         <p:spPr>
           <a:xfrm>
             <a:off x="335520" y="764640"/>
-            <a:ext cx="10738440" cy="489240"/>
+            <a:ext cx="10738080" cy="488880"/>
           </a:xfrm>
           <a:prstGeom prst="rect">
             <a:avLst/>
@@ -10502,7 +10502,7 @@
         <p:spPr>
           <a:xfrm>
             <a:off x="4923720" y="1257120"/>
-            <a:ext cx="1461240" cy="2162520"/>
+            <a:ext cx="1460880" cy="2162160"/>
           </a:xfrm>
           <a:prstGeom prst="rect">
             <a:avLst/>
@@ -10526,7 +10526,7 @@
         <p:spPr>
           <a:xfrm>
             <a:off x="2207880" y="4110120"/>
-            <a:ext cx="1775160" cy="1767240"/>
+            <a:ext cx="1774800" cy="1766880"/>
           </a:xfrm>
           <a:prstGeom prst="rect">
             <a:avLst/>
@@ -10546,7 +10546,7 @@
         <p:spPr>
           <a:xfrm>
             <a:off x="3859200" y="3373200"/>
-            <a:ext cx="3625920" cy="667440"/>
+            <a:ext cx="3625560" cy="667080"/>
           </a:xfrm>
           <a:prstGeom prst="rect">
             <a:avLst/>
@@ -10607,7 +10607,7 @@
         <p:spPr>
           <a:xfrm>
             <a:off x="1312200" y="5920200"/>
-            <a:ext cx="3625920" cy="667440"/>
+            <a:ext cx="3625560" cy="667080"/>
           </a:xfrm>
           <a:prstGeom prst="rect">
             <a:avLst/>
@@ -10648,7 +10648,7 @@
         <p:spPr>
           <a:xfrm>
             <a:off x="1312200" y="5807160"/>
-            <a:ext cx="3625920" cy="667440"/>
+            <a:ext cx="3625560" cy="667080"/>
           </a:xfrm>
           <a:prstGeom prst="rect">
             <a:avLst/>
@@ -10709,7 +10709,7 @@
         <p:spPr>
           <a:xfrm>
             <a:off x="4860000" y="5920200"/>
-            <a:ext cx="3625920" cy="667440"/>
+            <a:ext cx="3625560" cy="667080"/>
           </a:xfrm>
           <a:prstGeom prst="rect">
             <a:avLst/>
@@ -10750,7 +10750,7 @@
         <p:spPr>
           <a:xfrm>
             <a:off x="6300000" y="5807160"/>
-            <a:ext cx="3625920" cy="667440"/>
+            <a:ext cx="3625560" cy="667080"/>
           </a:xfrm>
           <a:prstGeom prst="rect">
             <a:avLst/>
@@ -10816,7 +10816,7 @@
         <p:spPr>
           <a:xfrm>
             <a:off x="7203960" y="4143960"/>
-            <a:ext cx="1794600" cy="1794600"/>
+            <a:ext cx="1794240" cy="1794240"/>
           </a:xfrm>
           <a:prstGeom prst="rect">
             <a:avLst/>
@@ -10866,7 +10866,7 @@
         <p:spPr>
           <a:xfrm>
             <a:off x="335520" y="764640"/>
-            <a:ext cx="10738440" cy="489240"/>
+            <a:ext cx="10738080" cy="488880"/>
           </a:xfrm>
           <a:prstGeom prst="rect">
             <a:avLst/>
@@ -10924,7 +10924,7 @@
         <p:spPr>
           <a:xfrm>
             <a:off x="335520" y="1268640"/>
-            <a:ext cx="10738440" cy="5025960"/>
+            <a:ext cx="10738080" cy="5025600"/>
           </a:xfrm>
           <a:prstGeom prst="rect">
             <a:avLst/>
@@ -11195,7 +11195,7 @@
         <p:spPr>
           <a:xfrm>
             <a:off x="335520" y="764640"/>
-            <a:ext cx="10736640" cy="487440"/>
+            <a:ext cx="10736280" cy="487080"/>
           </a:xfrm>
           <a:prstGeom prst="rect">
             <a:avLst/>
@@ -11253,7 +11253,7 @@
         <p:spPr>
           <a:xfrm>
             <a:off x="335520" y="1268280"/>
-            <a:ext cx="10736640" cy="5024160"/>
+            <a:ext cx="10736280" cy="5023800"/>
           </a:xfrm>
           <a:prstGeom prst="rect">
             <a:avLst/>
@@ -11359,7 +11359,7 @@
         <p:spPr>
           <a:xfrm>
             <a:off x="6285600" y="2132640"/>
-            <a:ext cx="506160" cy="486000"/>
+            <a:ext cx="505800" cy="485640"/>
           </a:xfrm>
           <a:prstGeom prst="star5">
             <a:avLst>
@@ -11416,7 +11416,7 @@
         <p:spPr>
           <a:xfrm>
             <a:off x="4089960" y="2247480"/>
-            <a:ext cx="2274480" cy="363960"/>
+            <a:ext cx="2274120" cy="363960"/>
           </a:xfrm>
           <a:prstGeom prst="rect">
             <a:avLst/>
@@ -11528,7 +11528,7 @@
         <p:spPr>
           <a:xfrm>
             <a:off x="335520" y="764640"/>
-            <a:ext cx="10736640" cy="487440"/>
+            <a:ext cx="10736280" cy="487080"/>
           </a:xfrm>
           <a:prstGeom prst="rect">
             <a:avLst/>
@@ -11586,7 +11586,7 @@
         <p:spPr>
           <a:xfrm>
             <a:off x="335520" y="1268640"/>
-            <a:ext cx="10736640" cy="5024160"/>
+            <a:ext cx="10736280" cy="5023800"/>
           </a:xfrm>
           <a:prstGeom prst="rect">
             <a:avLst/>
@@ -11655,19 +11655,7 @@
                 <a:latin typeface="DejaVu Sans"/>
                 <a:ea typeface="DejaVu Sans"/>
               </a:rPr>
-              <a:t> need to buy a book to pass the </a:t>
-            </a:r>
-            <a:r>
-              <a:rPr lang="en-US" sz="1800" b="0" u="none" strike="noStrike">
-                <a:solidFill>
-                  <a:srgbClr val="000000"/>
-                </a:solidFill>
-                <a:effectLst/>
-                <a:uFillTx/>
-                <a:latin typeface="DejaVu Sans"/>
-                <a:ea typeface="DejaVu Sans"/>
-              </a:rPr>
-              <a:t>exam.</a:t>
+              <a:t> need to buy a book to pass the exam.</a:t>
             </a:r>
             <a:endParaRPr lang="en-US" sz="1800" b="0" u="none" strike="noStrike">
               <a:solidFill>
@@ -11745,19 +11733,7 @@
                 <a:latin typeface="DejaVu Sans"/>
                 <a:ea typeface="DejaVu Sans"/>
               </a:rPr>
-              <a:t> </a:t>
-            </a:r>
-            <a:r>
-              <a:rPr lang="en-US" sz="1800" b="0" u="none" strike="noStrike">
-                <a:solidFill>
-                  <a:srgbClr val="000000"/>
-                </a:solidFill>
-                <a:effectLst/>
-                <a:uFillTx/>
-                <a:latin typeface="DejaVu Sans"/>
-                <a:ea typeface="DejaVu Sans"/>
-              </a:rPr>
-              <a:t>(1972).</a:t>
+              <a:t> (1972).</a:t>
             </a:r>
             <a:endParaRPr lang="en-US" sz="1800" b="0" u="none" strike="noStrike">
               <a:solidFill>
@@ -11805,19 +11781,7 @@
                 <a:latin typeface="DejaVu Sans"/>
                 <a:ea typeface="DejaVu Sans"/>
               </a:rPr>
-              <a:t>Limits To Growth: The 30-</a:t>
-            </a:r>
-            <a:r>
-              <a:rPr lang="en-US" sz="1800" b="0" i="1" u="none" strike="noStrike">
-                <a:solidFill>
-                  <a:srgbClr val="000000"/>
-                </a:solidFill>
-                <a:effectLst/>
-                <a:uFillTx/>
-                <a:latin typeface="DejaVu Sans"/>
-                <a:ea typeface="DejaVu Sans"/>
-              </a:rPr>
-              <a:t>Year Update</a:t>
+              <a:t>Limits To Growth: The 30-Year Update</a:t>
             </a:r>
             <a:r>
               <a:rPr lang="en-US" sz="1800" b="0" u="none" strike="noStrike">
@@ -12181,7 +12145,7 @@
         <p:spPr>
           <a:xfrm>
             <a:off x="335520" y="764640"/>
-            <a:ext cx="10738440" cy="489240"/>
+            <a:ext cx="10738080" cy="488880"/>
           </a:xfrm>
           <a:prstGeom prst="rect">
             <a:avLst/>
@@ -12239,7 +12203,7 @@
         <p:spPr>
           <a:xfrm>
             <a:off x="335520" y="1268640"/>
-            <a:ext cx="10738440" cy="5025960"/>
+            <a:ext cx="10738080" cy="5025600"/>
           </a:xfrm>
           <a:prstGeom prst="rect">
             <a:avLst/>
@@ -12558,7 +12522,7 @@
         <p:spPr>
           <a:xfrm>
             <a:off x="335520" y="1268640"/>
-            <a:ext cx="10738440" cy="5025960"/>
+            <a:ext cx="10738080" cy="5025600"/>
           </a:xfrm>
           <a:prstGeom prst="rect">
             <a:avLst/>
@@ -12622,7 +12586,7 @@
         <p:spPr>
           <a:xfrm>
             <a:off x="335520" y="764640"/>
-            <a:ext cx="10738440" cy="489240"/>
+            <a:ext cx="10738080" cy="488880"/>
           </a:xfrm>
           <a:prstGeom prst="rect">
             <a:avLst/>
@@ -12693,7 +12657,7 @@
         <p:spPr>
           <a:xfrm>
             <a:off x="542880" y="721800"/>
-            <a:ext cx="10342800" cy="483480"/>
+            <a:ext cx="10342440" cy="483120"/>
           </a:xfrm>
           <a:prstGeom prst="rect">
             <a:avLst/>
@@ -12751,7 +12715,7 @@
         <p:spPr>
           <a:xfrm>
             <a:off x="451800" y="1709280"/>
-            <a:ext cx="8210160" cy="4338360"/>
+            <a:ext cx="8209800" cy="4338000"/>
           </a:xfrm>
           <a:prstGeom prst="rect">
             <a:avLst/>
@@ -12792,7 +12756,7 @@
         <p:spPr>
           <a:xfrm>
             <a:off x="609480" y="1769400"/>
-            <a:ext cx="10573200" cy="4841280"/>
+            <a:ext cx="10572840" cy="4840920"/>
           </a:xfrm>
           <a:prstGeom prst="rect">
             <a:avLst/>
@@ -13273,7 +13237,7 @@
         <p:spPr>
           <a:xfrm>
             <a:off x="542880" y="721800"/>
-            <a:ext cx="10342800" cy="483480"/>
+            <a:ext cx="10342440" cy="483120"/>
           </a:xfrm>
           <a:prstGeom prst="rect">
             <a:avLst/>
@@ -13331,7 +13295,7 @@
         <p:spPr>
           <a:xfrm>
             <a:off x="451800" y="1709280"/>
-            <a:ext cx="8210160" cy="4338360"/>
+            <a:ext cx="8209800" cy="4338000"/>
           </a:xfrm>
           <a:prstGeom prst="rect">
             <a:avLst/>
@@ -13372,7 +13336,7 @@
         <p:spPr>
           <a:xfrm>
             <a:off x="609480" y="1769400"/>
-            <a:ext cx="10573200" cy="4841280"/>
+            <a:ext cx="10572840" cy="4840920"/>
           </a:xfrm>
           <a:prstGeom prst="rect">
             <a:avLst/>
@@ -13653,7 +13617,7 @@
         <p:spPr>
           <a:xfrm>
             <a:off x="542880" y="721800"/>
-            <a:ext cx="10342800" cy="483480"/>
+            <a:ext cx="10342440" cy="483120"/>
           </a:xfrm>
           <a:prstGeom prst="rect">
             <a:avLst/>
@@ -13711,7 +13675,7 @@
         <p:spPr>
           <a:xfrm>
             <a:off x="451800" y="1709280"/>
-            <a:ext cx="8210160" cy="4338360"/>
+            <a:ext cx="8209800" cy="4338000"/>
           </a:xfrm>
           <a:prstGeom prst="rect">
             <a:avLst/>
@@ -13752,7 +13716,7 @@
         <p:spPr>
           <a:xfrm>
             <a:off x="609480" y="1769400"/>
-            <a:ext cx="10573200" cy="4841280"/>
+            <a:ext cx="10572840" cy="4840920"/>
           </a:xfrm>
           <a:prstGeom prst="rect">
             <a:avLst/>
@@ -14033,7 +13997,7 @@
         <p:spPr>
           <a:xfrm>
             <a:off x="335520" y="764640"/>
-            <a:ext cx="10738440" cy="489240"/>
+            <a:ext cx="10738080" cy="488880"/>
           </a:xfrm>
           <a:prstGeom prst="rect">
             <a:avLst/>
@@ -14106,7 +14070,7 @@
         <p:spPr>
           <a:xfrm>
             <a:off x="335520" y="2408400"/>
-            <a:ext cx="10738440" cy="3886200"/>
+            <a:ext cx="10738080" cy="3885840"/>
           </a:xfrm>
           <a:prstGeom prst="rect">
             <a:avLst/>
@@ -14347,7 +14311,7 @@
         <p:spPr>
           <a:xfrm>
             <a:off x="335520" y="764640"/>
-            <a:ext cx="10738440" cy="489240"/>
+            <a:ext cx="10738080" cy="488880"/>
           </a:xfrm>
           <a:prstGeom prst="rect">
             <a:avLst/>
@@ -14405,7 +14369,7 @@
         <p:spPr>
           <a:xfrm>
             <a:off x="335520" y="1268640"/>
-            <a:ext cx="10738440" cy="5025960"/>
+            <a:ext cx="10738080" cy="5025600"/>
           </a:xfrm>
           <a:prstGeom prst="rect">
             <a:avLst/>
@@ -14916,7 +14880,7 @@
         <p:spPr>
           <a:xfrm>
             <a:off x="335520" y="764640"/>
-            <a:ext cx="10738440" cy="489240"/>
+            <a:ext cx="10738080" cy="488880"/>
           </a:xfrm>
           <a:prstGeom prst="rect">
             <a:avLst/>
@@ -14952,7 +14916,7 @@
                 <a:latin typeface="DejaVu Sans"/>
                 <a:ea typeface="DejaVu Sans"/>
               </a:rPr>
-              <a:t>Exercise Deadlines</a:t>
+              <a:t>Exercises (Deadlines)</a:t>
             </a:r>
             <a:endParaRPr lang="en-US" sz="2400" b="0" u="none" strike="noStrike">
               <a:solidFill>
@@ -14974,7 +14938,7 @@
         <p:spPr>
           <a:xfrm>
             <a:off x="335520" y="1268640"/>
-            <a:ext cx="10738440" cy="5025960"/>
+            <a:ext cx="10738080" cy="5025600"/>
           </a:xfrm>
           <a:prstGeom prst="rect">
             <a:avLst/>

</xml_diff>